<commit_message>
Update Azure Local deck: single accent colour
Co-Authored-By: Claude Sonnet 5.5 <noreply@anthropic.com>
</commit_message>
<xml_diff>
--- a/presentation/Azure_Local_Discovery_to_Day2_NIC2026.pptx
+++ b/presentation/Azure_Local_Discovery_to_Day2_NIC2026.pptx
@@ -6135,17 +6135,17 @@
         <p:spPr>
           <a:xfrm>
             <a:off x="0" y="0"/>
-            <a:ext cx="1750815" cy="128016"/>
+            <a:ext cx="12191695" cy="128016"/>
           </a:xfrm>
           <a:prstGeom prst="rect">
             <a:avLst/>
           </a:prstGeom>
           <a:solidFill>
-            <a:srgbClr val="FF6B6B"/>
+            <a:srgbClr val="6CC3FF"/>
           </a:solidFill>
           <a:ln w="12700">
             <a:solidFill>
-              <a:srgbClr val="FF6B6B"/>
+              <a:srgbClr val="6CC3FF"/>
             </a:solidFill>
             <a:prstDash val="solid"/>
           </a:ln>
@@ -6159,18 +6159,18 @@
         </p:nvSpPr>
         <p:spPr>
           <a:xfrm>
-            <a:off x="1741671" y="0"/>
-            <a:ext cx="1750815" cy="128016"/>
+            <a:off x="0" y="6729984"/>
+            <a:ext cx="12191695" cy="128016"/>
           </a:xfrm>
           <a:prstGeom prst="rect">
             <a:avLst/>
           </a:prstGeom>
           <a:solidFill>
-            <a:srgbClr val="FFA94D"/>
+            <a:srgbClr val="6CC3FF"/>
           </a:solidFill>
           <a:ln w="12700">
             <a:solidFill>
-              <a:srgbClr val="FFA94D"/>
+              <a:srgbClr val="6CC3FF"/>
             </a:solidFill>
             <a:prstDash val="solid"/>
           </a:ln>
@@ -6178,307 +6178,7 @@
       </p:sp>
       <p:sp>
         <p:nvSpPr>
-          <p:cNvPr id="4" name="Shape 2"/>
-          <p:cNvSpPr/>
-          <p:nvPr/>
-        </p:nvSpPr>
-        <p:spPr>
-          <a:xfrm>
-            <a:off x="3483341" y="0"/>
-            <a:ext cx="1750815" cy="128016"/>
-          </a:xfrm>
-          <a:prstGeom prst="rect">
-            <a:avLst/>
-          </a:prstGeom>
-          <a:solidFill>
-            <a:srgbClr val="FFE066"/>
-          </a:solidFill>
-          <a:ln w="12700">
-            <a:solidFill>
-              <a:srgbClr val="FFE066"/>
-            </a:solidFill>
-            <a:prstDash val="solid"/>
-          </a:ln>
-        </p:spPr>
-      </p:sp>
-      <p:sp>
-        <p:nvSpPr>
-          <p:cNvPr id="5" name="Shape 3"/>
-          <p:cNvSpPr/>
-          <p:nvPr/>
-        </p:nvSpPr>
-        <p:spPr>
-          <a:xfrm>
-            <a:off x="5225012" y="0"/>
-            <a:ext cx="1750815" cy="128016"/>
-          </a:xfrm>
-          <a:prstGeom prst="rect">
-            <a:avLst/>
-          </a:prstGeom>
-          <a:solidFill>
-            <a:srgbClr val="8CE99A"/>
-          </a:solidFill>
-          <a:ln w="12700">
-            <a:solidFill>
-              <a:srgbClr val="8CE99A"/>
-            </a:solidFill>
-            <a:prstDash val="solid"/>
-          </a:ln>
-        </p:spPr>
-      </p:sp>
-      <p:sp>
-        <p:nvSpPr>
-          <p:cNvPr id="6" name="Shape 4"/>
-          <p:cNvSpPr/>
-          <p:nvPr/>
-        </p:nvSpPr>
-        <p:spPr>
-          <a:xfrm>
-            <a:off x="6966683" y="0"/>
-            <a:ext cx="1750815" cy="128016"/>
-          </a:xfrm>
-          <a:prstGeom prst="rect">
-            <a:avLst/>
-          </a:prstGeom>
-          <a:solidFill>
-            <a:srgbClr val="66D9E8"/>
-          </a:solidFill>
-          <a:ln w="12700">
-            <a:solidFill>
-              <a:srgbClr val="66D9E8"/>
-            </a:solidFill>
-            <a:prstDash val="solid"/>
-          </a:ln>
-        </p:spPr>
-      </p:sp>
-      <p:sp>
-        <p:nvSpPr>
-          <p:cNvPr id="7" name="Shape 5"/>
-          <p:cNvSpPr/>
-          <p:nvPr/>
-        </p:nvSpPr>
-        <p:spPr>
-          <a:xfrm>
-            <a:off x="8708354" y="0"/>
-            <a:ext cx="1750815" cy="128016"/>
-          </a:xfrm>
-          <a:prstGeom prst="rect">
-            <a:avLst/>
-          </a:prstGeom>
-          <a:solidFill>
-            <a:srgbClr val="74C0FC"/>
-          </a:solidFill>
-          <a:ln w="12700">
-            <a:solidFill>
-              <a:srgbClr val="74C0FC"/>
-            </a:solidFill>
-            <a:prstDash val="solid"/>
-          </a:ln>
-        </p:spPr>
-      </p:sp>
-      <p:sp>
-        <p:nvSpPr>
-          <p:cNvPr id="8" name="Shape 6"/>
-          <p:cNvSpPr/>
-          <p:nvPr/>
-        </p:nvSpPr>
-        <p:spPr>
-          <a:xfrm>
-            <a:off x="10450024" y="0"/>
-            <a:ext cx="1750815" cy="128016"/>
-          </a:xfrm>
-          <a:prstGeom prst="rect">
-            <a:avLst/>
-          </a:prstGeom>
-          <a:solidFill>
-            <a:srgbClr val="B197FC"/>
-          </a:solidFill>
-          <a:ln w="12700">
-            <a:solidFill>
-              <a:srgbClr val="B197FC"/>
-            </a:solidFill>
-            <a:prstDash val="solid"/>
-          </a:ln>
-        </p:spPr>
-      </p:sp>
-      <p:sp>
-        <p:nvSpPr>
-          <p:cNvPr id="9" name="Shape 7"/>
-          <p:cNvSpPr/>
-          <p:nvPr/>
-        </p:nvSpPr>
-        <p:spPr>
-          <a:xfrm>
-            <a:off x="0" y="6729984"/>
-            <a:ext cx="1750815" cy="128016"/>
-          </a:xfrm>
-          <a:prstGeom prst="rect">
-            <a:avLst/>
-          </a:prstGeom>
-          <a:solidFill>
-            <a:srgbClr val="FF6B6B"/>
-          </a:solidFill>
-          <a:ln w="12700">
-            <a:solidFill>
-              <a:srgbClr val="FF6B6B"/>
-            </a:solidFill>
-            <a:prstDash val="solid"/>
-          </a:ln>
-        </p:spPr>
-      </p:sp>
-      <p:sp>
-        <p:nvSpPr>
-          <p:cNvPr id="10" name="Shape 8"/>
-          <p:cNvSpPr/>
-          <p:nvPr/>
-        </p:nvSpPr>
-        <p:spPr>
-          <a:xfrm>
-            <a:off x="1741671" y="6729984"/>
-            <a:ext cx="1750815" cy="128016"/>
-          </a:xfrm>
-          <a:prstGeom prst="rect">
-            <a:avLst/>
-          </a:prstGeom>
-          <a:solidFill>
-            <a:srgbClr val="FFA94D"/>
-          </a:solidFill>
-          <a:ln w="12700">
-            <a:solidFill>
-              <a:srgbClr val="FFA94D"/>
-            </a:solidFill>
-            <a:prstDash val="solid"/>
-          </a:ln>
-        </p:spPr>
-      </p:sp>
-      <p:sp>
-        <p:nvSpPr>
-          <p:cNvPr id="11" name="Shape 9"/>
-          <p:cNvSpPr/>
-          <p:nvPr/>
-        </p:nvSpPr>
-        <p:spPr>
-          <a:xfrm>
-            <a:off x="3483341" y="6729984"/>
-            <a:ext cx="1750815" cy="128016"/>
-          </a:xfrm>
-          <a:prstGeom prst="rect">
-            <a:avLst/>
-          </a:prstGeom>
-          <a:solidFill>
-            <a:srgbClr val="FFE066"/>
-          </a:solidFill>
-          <a:ln w="12700">
-            <a:solidFill>
-              <a:srgbClr val="FFE066"/>
-            </a:solidFill>
-            <a:prstDash val="solid"/>
-          </a:ln>
-        </p:spPr>
-      </p:sp>
-      <p:sp>
-        <p:nvSpPr>
-          <p:cNvPr id="12" name="Shape 10"/>
-          <p:cNvSpPr/>
-          <p:nvPr/>
-        </p:nvSpPr>
-        <p:spPr>
-          <a:xfrm>
-            <a:off x="5225012" y="6729984"/>
-            <a:ext cx="1750815" cy="128016"/>
-          </a:xfrm>
-          <a:prstGeom prst="rect">
-            <a:avLst/>
-          </a:prstGeom>
-          <a:solidFill>
-            <a:srgbClr val="8CE99A"/>
-          </a:solidFill>
-          <a:ln w="12700">
-            <a:solidFill>
-              <a:srgbClr val="8CE99A"/>
-            </a:solidFill>
-            <a:prstDash val="solid"/>
-          </a:ln>
-        </p:spPr>
-      </p:sp>
-      <p:sp>
-        <p:nvSpPr>
-          <p:cNvPr id="13" name="Shape 11"/>
-          <p:cNvSpPr/>
-          <p:nvPr/>
-        </p:nvSpPr>
-        <p:spPr>
-          <a:xfrm>
-            <a:off x="6966683" y="6729984"/>
-            <a:ext cx="1750815" cy="128016"/>
-          </a:xfrm>
-          <a:prstGeom prst="rect">
-            <a:avLst/>
-          </a:prstGeom>
-          <a:solidFill>
-            <a:srgbClr val="66D9E8"/>
-          </a:solidFill>
-          <a:ln w="12700">
-            <a:solidFill>
-              <a:srgbClr val="66D9E8"/>
-            </a:solidFill>
-            <a:prstDash val="solid"/>
-          </a:ln>
-        </p:spPr>
-      </p:sp>
-      <p:sp>
-        <p:nvSpPr>
-          <p:cNvPr id="14" name="Shape 12"/>
-          <p:cNvSpPr/>
-          <p:nvPr/>
-        </p:nvSpPr>
-        <p:spPr>
-          <a:xfrm>
-            <a:off x="8708354" y="6729984"/>
-            <a:ext cx="1750815" cy="128016"/>
-          </a:xfrm>
-          <a:prstGeom prst="rect">
-            <a:avLst/>
-          </a:prstGeom>
-          <a:solidFill>
-            <a:srgbClr val="74C0FC"/>
-          </a:solidFill>
-          <a:ln w="12700">
-            <a:solidFill>
-              <a:srgbClr val="74C0FC"/>
-            </a:solidFill>
-            <a:prstDash val="solid"/>
-          </a:ln>
-        </p:spPr>
-      </p:sp>
-      <p:sp>
-        <p:nvSpPr>
-          <p:cNvPr id="15" name="Shape 13"/>
-          <p:cNvSpPr/>
-          <p:nvPr/>
-        </p:nvSpPr>
-        <p:spPr>
-          <a:xfrm>
-            <a:off x="10450024" y="6729984"/>
-            <a:ext cx="1750815" cy="128016"/>
-          </a:xfrm>
-          <a:prstGeom prst="rect">
-            <a:avLst/>
-          </a:prstGeom>
-          <a:solidFill>
-            <a:srgbClr val="B197FC"/>
-          </a:solidFill>
-          <a:ln w="12700">
-            <a:solidFill>
-              <a:srgbClr val="B197FC"/>
-            </a:solidFill>
-            <a:prstDash val="solid"/>
-          </a:ln>
-        </p:spPr>
-      </p:sp>
-      <p:sp>
-        <p:nvSpPr>
-          <p:cNvPr id="16" name="Text 14"/>
+          <p:cNvPr id="4" name="Text 2"/>
           <p:cNvSpPr/>
           <p:nvPr/>
         </p:nvSpPr>
@@ -6519,7 +6219,7 @@
       </p:sp>
       <p:sp>
         <p:nvSpPr>
-          <p:cNvPr id="17" name="Text 15"/>
+          <p:cNvPr id="5" name="Text 3"/>
           <p:cNvSpPr/>
           <p:nvPr/>
         </p:nvSpPr>
@@ -12587,17 +12287,17 @@
         <p:spPr>
           <a:xfrm>
             <a:off x="0" y="0"/>
-            <a:ext cx="1750815" cy="128016"/>
+            <a:ext cx="12191695" cy="128016"/>
           </a:xfrm>
           <a:prstGeom prst="rect">
             <a:avLst/>
           </a:prstGeom>
           <a:solidFill>
-            <a:srgbClr val="FF6B6B"/>
+            <a:srgbClr val="6CC3FF"/>
           </a:solidFill>
           <a:ln w="12700">
             <a:solidFill>
-              <a:srgbClr val="FF6B6B"/>
+              <a:srgbClr val="6CC3FF"/>
             </a:solidFill>
             <a:prstDash val="solid"/>
           </a:ln>
@@ -12605,157 +12305,7 @@
       </p:sp>
       <p:sp>
         <p:nvSpPr>
-          <p:cNvPr id="3" name="Shape 1"/>
-          <p:cNvSpPr/>
-          <p:nvPr/>
-        </p:nvSpPr>
-        <p:spPr>
-          <a:xfrm>
-            <a:off x="1741671" y="0"/>
-            <a:ext cx="1750815" cy="128016"/>
-          </a:xfrm>
-          <a:prstGeom prst="rect">
-            <a:avLst/>
-          </a:prstGeom>
-          <a:solidFill>
-            <a:srgbClr val="FFA94D"/>
-          </a:solidFill>
-          <a:ln w="12700">
-            <a:solidFill>
-              <a:srgbClr val="FFA94D"/>
-            </a:solidFill>
-            <a:prstDash val="solid"/>
-          </a:ln>
-        </p:spPr>
-      </p:sp>
-      <p:sp>
-        <p:nvSpPr>
-          <p:cNvPr id="4" name="Shape 2"/>
-          <p:cNvSpPr/>
-          <p:nvPr/>
-        </p:nvSpPr>
-        <p:spPr>
-          <a:xfrm>
-            <a:off x="3483341" y="0"/>
-            <a:ext cx="1750815" cy="128016"/>
-          </a:xfrm>
-          <a:prstGeom prst="rect">
-            <a:avLst/>
-          </a:prstGeom>
-          <a:solidFill>
-            <a:srgbClr val="FFE066"/>
-          </a:solidFill>
-          <a:ln w="12700">
-            <a:solidFill>
-              <a:srgbClr val="FFE066"/>
-            </a:solidFill>
-            <a:prstDash val="solid"/>
-          </a:ln>
-        </p:spPr>
-      </p:sp>
-      <p:sp>
-        <p:nvSpPr>
-          <p:cNvPr id="5" name="Shape 3"/>
-          <p:cNvSpPr/>
-          <p:nvPr/>
-        </p:nvSpPr>
-        <p:spPr>
-          <a:xfrm>
-            <a:off x="5225012" y="0"/>
-            <a:ext cx="1750815" cy="128016"/>
-          </a:xfrm>
-          <a:prstGeom prst="rect">
-            <a:avLst/>
-          </a:prstGeom>
-          <a:solidFill>
-            <a:srgbClr val="8CE99A"/>
-          </a:solidFill>
-          <a:ln w="12700">
-            <a:solidFill>
-              <a:srgbClr val="8CE99A"/>
-            </a:solidFill>
-            <a:prstDash val="solid"/>
-          </a:ln>
-        </p:spPr>
-      </p:sp>
-      <p:sp>
-        <p:nvSpPr>
-          <p:cNvPr id="6" name="Shape 4"/>
-          <p:cNvSpPr/>
-          <p:nvPr/>
-        </p:nvSpPr>
-        <p:spPr>
-          <a:xfrm>
-            <a:off x="6966683" y="0"/>
-            <a:ext cx="1750815" cy="128016"/>
-          </a:xfrm>
-          <a:prstGeom prst="rect">
-            <a:avLst/>
-          </a:prstGeom>
-          <a:solidFill>
-            <a:srgbClr val="66D9E8"/>
-          </a:solidFill>
-          <a:ln w="12700">
-            <a:solidFill>
-              <a:srgbClr val="66D9E8"/>
-            </a:solidFill>
-            <a:prstDash val="solid"/>
-          </a:ln>
-        </p:spPr>
-      </p:sp>
-      <p:sp>
-        <p:nvSpPr>
-          <p:cNvPr id="7" name="Shape 5"/>
-          <p:cNvSpPr/>
-          <p:nvPr/>
-        </p:nvSpPr>
-        <p:spPr>
-          <a:xfrm>
-            <a:off x="8708354" y="0"/>
-            <a:ext cx="1750815" cy="128016"/>
-          </a:xfrm>
-          <a:prstGeom prst="rect">
-            <a:avLst/>
-          </a:prstGeom>
-          <a:solidFill>
-            <a:srgbClr val="74C0FC"/>
-          </a:solidFill>
-          <a:ln w="12700">
-            <a:solidFill>
-              <a:srgbClr val="74C0FC"/>
-            </a:solidFill>
-            <a:prstDash val="solid"/>
-          </a:ln>
-        </p:spPr>
-      </p:sp>
-      <p:sp>
-        <p:nvSpPr>
-          <p:cNvPr id="8" name="Shape 6"/>
-          <p:cNvSpPr/>
-          <p:nvPr/>
-        </p:nvSpPr>
-        <p:spPr>
-          <a:xfrm>
-            <a:off x="10450024" y="0"/>
-            <a:ext cx="1750815" cy="128016"/>
-          </a:xfrm>
-          <a:prstGeom prst="rect">
-            <a:avLst/>
-          </a:prstGeom>
-          <a:solidFill>
-            <a:srgbClr val="B197FC"/>
-          </a:solidFill>
-          <a:ln w="12700">
-            <a:solidFill>
-              <a:srgbClr val="B197FC"/>
-            </a:solidFill>
-            <a:prstDash val="solid"/>
-          </a:ln>
-        </p:spPr>
-      </p:sp>
-      <p:sp>
-        <p:nvSpPr>
-          <p:cNvPr id="9" name="Text 7"/>
+          <p:cNvPr id="3" name="Text 1"/>
           <p:cNvSpPr/>
           <p:nvPr/>
         </p:nvSpPr>
@@ -12794,7 +12344,7 @@
       </p:sp>
       <p:sp>
         <p:nvSpPr>
-          <p:cNvPr id="10" name="Text 8"/>
+          <p:cNvPr id="4" name="Text 2"/>
           <p:cNvSpPr/>
           <p:nvPr/>
         </p:nvSpPr>
@@ -12835,7 +12385,7 @@
       </p:sp>
       <p:sp>
         <p:nvSpPr>
-          <p:cNvPr id="11" name="Text 9"/>
+          <p:cNvPr id="5" name="Text 3"/>
           <p:cNvSpPr/>
           <p:nvPr/>
         </p:nvSpPr>
@@ -16188,17 +15738,17 @@
         <p:spPr>
           <a:xfrm>
             <a:off x="0" y="0"/>
-            <a:ext cx="1750815" cy="128016"/>
+            <a:ext cx="12191695" cy="128016"/>
           </a:xfrm>
           <a:prstGeom prst="rect">
             <a:avLst/>
           </a:prstGeom>
           <a:solidFill>
-            <a:srgbClr val="FF6B6B"/>
+            <a:srgbClr val="6CC3FF"/>
           </a:solidFill>
           <a:ln w="12700">
             <a:solidFill>
-              <a:srgbClr val="FF6B6B"/>
+              <a:srgbClr val="6CC3FF"/>
             </a:solidFill>
             <a:prstDash val="solid"/>
           </a:ln>
@@ -16206,157 +15756,7 @@
       </p:sp>
       <p:sp>
         <p:nvSpPr>
-          <p:cNvPr id="3" name="Shape 1"/>
-          <p:cNvSpPr/>
-          <p:nvPr/>
-        </p:nvSpPr>
-        <p:spPr>
-          <a:xfrm>
-            <a:off x="1741671" y="0"/>
-            <a:ext cx="1750815" cy="128016"/>
-          </a:xfrm>
-          <a:prstGeom prst="rect">
-            <a:avLst/>
-          </a:prstGeom>
-          <a:solidFill>
-            <a:srgbClr val="FFA94D"/>
-          </a:solidFill>
-          <a:ln w="12700">
-            <a:solidFill>
-              <a:srgbClr val="FFA94D"/>
-            </a:solidFill>
-            <a:prstDash val="solid"/>
-          </a:ln>
-        </p:spPr>
-      </p:sp>
-      <p:sp>
-        <p:nvSpPr>
-          <p:cNvPr id="4" name="Shape 2"/>
-          <p:cNvSpPr/>
-          <p:nvPr/>
-        </p:nvSpPr>
-        <p:spPr>
-          <a:xfrm>
-            <a:off x="3483341" y="0"/>
-            <a:ext cx="1750815" cy="128016"/>
-          </a:xfrm>
-          <a:prstGeom prst="rect">
-            <a:avLst/>
-          </a:prstGeom>
-          <a:solidFill>
-            <a:srgbClr val="FFE066"/>
-          </a:solidFill>
-          <a:ln w="12700">
-            <a:solidFill>
-              <a:srgbClr val="FFE066"/>
-            </a:solidFill>
-            <a:prstDash val="solid"/>
-          </a:ln>
-        </p:spPr>
-      </p:sp>
-      <p:sp>
-        <p:nvSpPr>
-          <p:cNvPr id="5" name="Shape 3"/>
-          <p:cNvSpPr/>
-          <p:nvPr/>
-        </p:nvSpPr>
-        <p:spPr>
-          <a:xfrm>
-            <a:off x="5225012" y="0"/>
-            <a:ext cx="1750815" cy="128016"/>
-          </a:xfrm>
-          <a:prstGeom prst="rect">
-            <a:avLst/>
-          </a:prstGeom>
-          <a:solidFill>
-            <a:srgbClr val="8CE99A"/>
-          </a:solidFill>
-          <a:ln w="12700">
-            <a:solidFill>
-              <a:srgbClr val="8CE99A"/>
-            </a:solidFill>
-            <a:prstDash val="solid"/>
-          </a:ln>
-        </p:spPr>
-      </p:sp>
-      <p:sp>
-        <p:nvSpPr>
-          <p:cNvPr id="6" name="Shape 4"/>
-          <p:cNvSpPr/>
-          <p:nvPr/>
-        </p:nvSpPr>
-        <p:spPr>
-          <a:xfrm>
-            <a:off x="6966683" y="0"/>
-            <a:ext cx="1750815" cy="128016"/>
-          </a:xfrm>
-          <a:prstGeom prst="rect">
-            <a:avLst/>
-          </a:prstGeom>
-          <a:solidFill>
-            <a:srgbClr val="66D9E8"/>
-          </a:solidFill>
-          <a:ln w="12700">
-            <a:solidFill>
-              <a:srgbClr val="66D9E8"/>
-            </a:solidFill>
-            <a:prstDash val="solid"/>
-          </a:ln>
-        </p:spPr>
-      </p:sp>
-      <p:sp>
-        <p:nvSpPr>
-          <p:cNvPr id="7" name="Shape 5"/>
-          <p:cNvSpPr/>
-          <p:nvPr/>
-        </p:nvSpPr>
-        <p:spPr>
-          <a:xfrm>
-            <a:off x="8708354" y="0"/>
-            <a:ext cx="1750815" cy="128016"/>
-          </a:xfrm>
-          <a:prstGeom prst="rect">
-            <a:avLst/>
-          </a:prstGeom>
-          <a:solidFill>
-            <a:srgbClr val="74C0FC"/>
-          </a:solidFill>
-          <a:ln w="12700">
-            <a:solidFill>
-              <a:srgbClr val="74C0FC"/>
-            </a:solidFill>
-            <a:prstDash val="solid"/>
-          </a:ln>
-        </p:spPr>
-      </p:sp>
-      <p:sp>
-        <p:nvSpPr>
-          <p:cNvPr id="8" name="Shape 6"/>
-          <p:cNvSpPr/>
-          <p:nvPr/>
-        </p:nvSpPr>
-        <p:spPr>
-          <a:xfrm>
-            <a:off x="10450024" y="0"/>
-            <a:ext cx="1750815" cy="128016"/>
-          </a:xfrm>
-          <a:prstGeom prst="rect">
-            <a:avLst/>
-          </a:prstGeom>
-          <a:solidFill>
-            <a:srgbClr val="B197FC"/>
-          </a:solidFill>
-          <a:ln w="12700">
-            <a:solidFill>
-              <a:srgbClr val="B197FC"/>
-            </a:solidFill>
-            <a:prstDash val="solid"/>
-          </a:ln>
-        </p:spPr>
-      </p:sp>
-      <p:sp>
-        <p:nvSpPr>
-          <p:cNvPr id="9" name="Text 7"/>
+          <p:cNvPr id="3" name="Text 1"/>
           <p:cNvSpPr/>
           <p:nvPr/>
         </p:nvSpPr>
@@ -16395,7 +15795,7 @@
       </p:sp>
       <p:sp>
         <p:nvSpPr>
-          <p:cNvPr id="10" name="Text 8"/>
+          <p:cNvPr id="4" name="Text 2"/>
           <p:cNvSpPr/>
           <p:nvPr/>
         </p:nvSpPr>
@@ -16436,7 +15836,7 @@
       </p:sp>
       <p:sp>
         <p:nvSpPr>
-          <p:cNvPr id="11" name="Text 9"/>
+          <p:cNvPr id="5" name="Text 3"/>
           <p:cNvSpPr/>
           <p:nvPr/>
         </p:nvSpPr>
@@ -19632,17 +19032,17 @@
         <p:spPr>
           <a:xfrm>
             <a:off x="0" y="0"/>
-            <a:ext cx="1750815" cy="128016"/>
+            <a:ext cx="12191695" cy="128016"/>
           </a:xfrm>
           <a:prstGeom prst="rect">
             <a:avLst/>
           </a:prstGeom>
           <a:solidFill>
-            <a:srgbClr val="FF6B6B"/>
+            <a:srgbClr val="6CC3FF"/>
           </a:solidFill>
           <a:ln w="12700">
             <a:solidFill>
-              <a:srgbClr val="FF6B6B"/>
+              <a:srgbClr val="6CC3FF"/>
             </a:solidFill>
             <a:prstDash val="solid"/>
           </a:ln>
@@ -19650,157 +19050,7 @@
       </p:sp>
       <p:sp>
         <p:nvSpPr>
-          <p:cNvPr id="3" name="Shape 1"/>
-          <p:cNvSpPr/>
-          <p:nvPr/>
-        </p:nvSpPr>
-        <p:spPr>
-          <a:xfrm>
-            <a:off x="1741671" y="0"/>
-            <a:ext cx="1750815" cy="128016"/>
-          </a:xfrm>
-          <a:prstGeom prst="rect">
-            <a:avLst/>
-          </a:prstGeom>
-          <a:solidFill>
-            <a:srgbClr val="FFA94D"/>
-          </a:solidFill>
-          <a:ln w="12700">
-            <a:solidFill>
-              <a:srgbClr val="FFA94D"/>
-            </a:solidFill>
-            <a:prstDash val="solid"/>
-          </a:ln>
-        </p:spPr>
-      </p:sp>
-      <p:sp>
-        <p:nvSpPr>
-          <p:cNvPr id="4" name="Shape 2"/>
-          <p:cNvSpPr/>
-          <p:nvPr/>
-        </p:nvSpPr>
-        <p:spPr>
-          <a:xfrm>
-            <a:off x="3483341" y="0"/>
-            <a:ext cx="1750815" cy="128016"/>
-          </a:xfrm>
-          <a:prstGeom prst="rect">
-            <a:avLst/>
-          </a:prstGeom>
-          <a:solidFill>
-            <a:srgbClr val="FFE066"/>
-          </a:solidFill>
-          <a:ln w="12700">
-            <a:solidFill>
-              <a:srgbClr val="FFE066"/>
-            </a:solidFill>
-            <a:prstDash val="solid"/>
-          </a:ln>
-        </p:spPr>
-      </p:sp>
-      <p:sp>
-        <p:nvSpPr>
-          <p:cNvPr id="5" name="Shape 3"/>
-          <p:cNvSpPr/>
-          <p:nvPr/>
-        </p:nvSpPr>
-        <p:spPr>
-          <a:xfrm>
-            <a:off x="5225012" y="0"/>
-            <a:ext cx="1750815" cy="128016"/>
-          </a:xfrm>
-          <a:prstGeom prst="rect">
-            <a:avLst/>
-          </a:prstGeom>
-          <a:solidFill>
-            <a:srgbClr val="8CE99A"/>
-          </a:solidFill>
-          <a:ln w="12700">
-            <a:solidFill>
-              <a:srgbClr val="8CE99A"/>
-            </a:solidFill>
-            <a:prstDash val="solid"/>
-          </a:ln>
-        </p:spPr>
-      </p:sp>
-      <p:sp>
-        <p:nvSpPr>
-          <p:cNvPr id="6" name="Shape 4"/>
-          <p:cNvSpPr/>
-          <p:nvPr/>
-        </p:nvSpPr>
-        <p:spPr>
-          <a:xfrm>
-            <a:off x="6966683" y="0"/>
-            <a:ext cx="1750815" cy="128016"/>
-          </a:xfrm>
-          <a:prstGeom prst="rect">
-            <a:avLst/>
-          </a:prstGeom>
-          <a:solidFill>
-            <a:srgbClr val="66D9E8"/>
-          </a:solidFill>
-          <a:ln w="12700">
-            <a:solidFill>
-              <a:srgbClr val="66D9E8"/>
-            </a:solidFill>
-            <a:prstDash val="solid"/>
-          </a:ln>
-        </p:spPr>
-      </p:sp>
-      <p:sp>
-        <p:nvSpPr>
-          <p:cNvPr id="7" name="Shape 5"/>
-          <p:cNvSpPr/>
-          <p:nvPr/>
-        </p:nvSpPr>
-        <p:spPr>
-          <a:xfrm>
-            <a:off x="8708354" y="0"/>
-            <a:ext cx="1750815" cy="128016"/>
-          </a:xfrm>
-          <a:prstGeom prst="rect">
-            <a:avLst/>
-          </a:prstGeom>
-          <a:solidFill>
-            <a:srgbClr val="74C0FC"/>
-          </a:solidFill>
-          <a:ln w="12700">
-            <a:solidFill>
-              <a:srgbClr val="74C0FC"/>
-            </a:solidFill>
-            <a:prstDash val="solid"/>
-          </a:ln>
-        </p:spPr>
-      </p:sp>
-      <p:sp>
-        <p:nvSpPr>
-          <p:cNvPr id="8" name="Shape 6"/>
-          <p:cNvSpPr/>
-          <p:nvPr/>
-        </p:nvSpPr>
-        <p:spPr>
-          <a:xfrm>
-            <a:off x="10450024" y="0"/>
-            <a:ext cx="1750815" cy="128016"/>
-          </a:xfrm>
-          <a:prstGeom prst="rect">
-            <a:avLst/>
-          </a:prstGeom>
-          <a:solidFill>
-            <a:srgbClr val="B197FC"/>
-          </a:solidFill>
-          <a:ln w="12700">
-            <a:solidFill>
-              <a:srgbClr val="B197FC"/>
-            </a:solidFill>
-            <a:prstDash val="solid"/>
-          </a:ln>
-        </p:spPr>
-      </p:sp>
-      <p:sp>
-        <p:nvSpPr>
-          <p:cNvPr id="9" name="Text 7"/>
+          <p:cNvPr id="3" name="Text 1"/>
           <p:cNvSpPr/>
           <p:nvPr/>
         </p:nvSpPr>
@@ -19839,7 +19089,7 @@
       </p:sp>
       <p:sp>
         <p:nvSpPr>
-          <p:cNvPr id="10" name="Text 8"/>
+          <p:cNvPr id="4" name="Text 2"/>
           <p:cNvSpPr/>
           <p:nvPr/>
         </p:nvSpPr>
@@ -19880,7 +19130,7 @@
       </p:sp>
       <p:sp>
         <p:nvSpPr>
-          <p:cNvPr id="11" name="Text 9"/>
+          <p:cNvPr id="5" name="Text 3"/>
           <p:cNvSpPr/>
           <p:nvPr/>
         </p:nvSpPr>
@@ -20313,17 +19563,17 @@
         <p:spPr>
           <a:xfrm>
             <a:off x="0" y="0"/>
-            <a:ext cx="1750815" cy="128016"/>
+            <a:ext cx="12191695" cy="128016"/>
           </a:xfrm>
           <a:prstGeom prst="rect">
             <a:avLst/>
           </a:prstGeom>
           <a:solidFill>
-            <a:srgbClr val="FF6B6B"/>
+            <a:srgbClr val="6CC3FF"/>
           </a:solidFill>
           <a:ln w="12700">
             <a:solidFill>
-              <a:srgbClr val="FF6B6B"/>
+              <a:srgbClr val="6CC3FF"/>
             </a:solidFill>
             <a:prstDash val="solid"/>
           </a:ln>
@@ -20331,157 +19581,7 @@
       </p:sp>
       <p:sp>
         <p:nvSpPr>
-          <p:cNvPr id="3" name="Shape 1"/>
-          <p:cNvSpPr/>
-          <p:nvPr/>
-        </p:nvSpPr>
-        <p:spPr>
-          <a:xfrm>
-            <a:off x="1741671" y="0"/>
-            <a:ext cx="1750815" cy="128016"/>
-          </a:xfrm>
-          <a:prstGeom prst="rect">
-            <a:avLst/>
-          </a:prstGeom>
-          <a:solidFill>
-            <a:srgbClr val="FFA94D"/>
-          </a:solidFill>
-          <a:ln w="12700">
-            <a:solidFill>
-              <a:srgbClr val="FFA94D"/>
-            </a:solidFill>
-            <a:prstDash val="solid"/>
-          </a:ln>
-        </p:spPr>
-      </p:sp>
-      <p:sp>
-        <p:nvSpPr>
-          <p:cNvPr id="4" name="Shape 2"/>
-          <p:cNvSpPr/>
-          <p:nvPr/>
-        </p:nvSpPr>
-        <p:spPr>
-          <a:xfrm>
-            <a:off x="3483341" y="0"/>
-            <a:ext cx="1750815" cy="128016"/>
-          </a:xfrm>
-          <a:prstGeom prst="rect">
-            <a:avLst/>
-          </a:prstGeom>
-          <a:solidFill>
-            <a:srgbClr val="FFE066"/>
-          </a:solidFill>
-          <a:ln w="12700">
-            <a:solidFill>
-              <a:srgbClr val="FFE066"/>
-            </a:solidFill>
-            <a:prstDash val="solid"/>
-          </a:ln>
-        </p:spPr>
-      </p:sp>
-      <p:sp>
-        <p:nvSpPr>
-          <p:cNvPr id="5" name="Shape 3"/>
-          <p:cNvSpPr/>
-          <p:nvPr/>
-        </p:nvSpPr>
-        <p:spPr>
-          <a:xfrm>
-            <a:off x="5225012" y="0"/>
-            <a:ext cx="1750815" cy="128016"/>
-          </a:xfrm>
-          <a:prstGeom prst="rect">
-            <a:avLst/>
-          </a:prstGeom>
-          <a:solidFill>
-            <a:srgbClr val="8CE99A"/>
-          </a:solidFill>
-          <a:ln w="12700">
-            <a:solidFill>
-              <a:srgbClr val="8CE99A"/>
-            </a:solidFill>
-            <a:prstDash val="solid"/>
-          </a:ln>
-        </p:spPr>
-      </p:sp>
-      <p:sp>
-        <p:nvSpPr>
-          <p:cNvPr id="6" name="Shape 4"/>
-          <p:cNvSpPr/>
-          <p:nvPr/>
-        </p:nvSpPr>
-        <p:spPr>
-          <a:xfrm>
-            <a:off x="6966683" y="0"/>
-            <a:ext cx="1750815" cy="128016"/>
-          </a:xfrm>
-          <a:prstGeom prst="rect">
-            <a:avLst/>
-          </a:prstGeom>
-          <a:solidFill>
-            <a:srgbClr val="66D9E8"/>
-          </a:solidFill>
-          <a:ln w="12700">
-            <a:solidFill>
-              <a:srgbClr val="66D9E8"/>
-            </a:solidFill>
-            <a:prstDash val="solid"/>
-          </a:ln>
-        </p:spPr>
-      </p:sp>
-      <p:sp>
-        <p:nvSpPr>
-          <p:cNvPr id="7" name="Shape 5"/>
-          <p:cNvSpPr/>
-          <p:nvPr/>
-        </p:nvSpPr>
-        <p:spPr>
-          <a:xfrm>
-            <a:off x="8708354" y="0"/>
-            <a:ext cx="1750815" cy="128016"/>
-          </a:xfrm>
-          <a:prstGeom prst="rect">
-            <a:avLst/>
-          </a:prstGeom>
-          <a:solidFill>
-            <a:srgbClr val="74C0FC"/>
-          </a:solidFill>
-          <a:ln w="12700">
-            <a:solidFill>
-              <a:srgbClr val="74C0FC"/>
-            </a:solidFill>
-            <a:prstDash val="solid"/>
-          </a:ln>
-        </p:spPr>
-      </p:sp>
-      <p:sp>
-        <p:nvSpPr>
-          <p:cNvPr id="8" name="Shape 6"/>
-          <p:cNvSpPr/>
-          <p:nvPr/>
-        </p:nvSpPr>
-        <p:spPr>
-          <a:xfrm>
-            <a:off x="10450024" y="0"/>
-            <a:ext cx="1750815" cy="128016"/>
-          </a:xfrm>
-          <a:prstGeom prst="rect">
-            <a:avLst/>
-          </a:prstGeom>
-          <a:solidFill>
-            <a:srgbClr val="B197FC"/>
-          </a:solidFill>
-          <a:ln w="12700">
-            <a:solidFill>
-              <a:srgbClr val="B197FC"/>
-            </a:solidFill>
-            <a:prstDash val="solid"/>
-          </a:ln>
-        </p:spPr>
-      </p:sp>
-      <p:sp>
-        <p:nvSpPr>
-          <p:cNvPr id="9" name="Text 7"/>
+          <p:cNvPr id="3" name="Text 1"/>
           <p:cNvSpPr/>
           <p:nvPr/>
         </p:nvSpPr>
@@ -20520,7 +19620,7 @@
       </p:sp>
       <p:sp>
         <p:nvSpPr>
-          <p:cNvPr id="10" name="Text 8"/>
+          <p:cNvPr id="4" name="Text 2"/>
           <p:cNvSpPr/>
           <p:nvPr/>
         </p:nvSpPr>
@@ -20561,7 +19661,7 @@
       </p:sp>
       <p:sp>
         <p:nvSpPr>
-          <p:cNvPr id="11" name="Text 9"/>
+          <p:cNvPr id="5" name="Text 3"/>
           <p:cNvSpPr/>
           <p:nvPr/>
         </p:nvSpPr>
@@ -24601,17 +23701,17 @@
         <p:spPr>
           <a:xfrm>
             <a:off x="0" y="0"/>
-            <a:ext cx="1750815" cy="128016"/>
+            <a:ext cx="12191695" cy="128016"/>
           </a:xfrm>
           <a:prstGeom prst="rect">
             <a:avLst/>
           </a:prstGeom>
           <a:solidFill>
-            <a:srgbClr val="FF6B6B"/>
+            <a:srgbClr val="6CC3FF"/>
           </a:solidFill>
           <a:ln w="12700">
             <a:solidFill>
-              <a:srgbClr val="FF6B6B"/>
+              <a:srgbClr val="6CC3FF"/>
             </a:solidFill>
             <a:prstDash val="solid"/>
           </a:ln>
@@ -24619,157 +23719,7 @@
       </p:sp>
       <p:sp>
         <p:nvSpPr>
-          <p:cNvPr id="3" name="Shape 1"/>
-          <p:cNvSpPr/>
-          <p:nvPr/>
-        </p:nvSpPr>
-        <p:spPr>
-          <a:xfrm>
-            <a:off x="1741671" y="0"/>
-            <a:ext cx="1750815" cy="128016"/>
-          </a:xfrm>
-          <a:prstGeom prst="rect">
-            <a:avLst/>
-          </a:prstGeom>
-          <a:solidFill>
-            <a:srgbClr val="FFA94D"/>
-          </a:solidFill>
-          <a:ln w="12700">
-            <a:solidFill>
-              <a:srgbClr val="FFA94D"/>
-            </a:solidFill>
-            <a:prstDash val="solid"/>
-          </a:ln>
-        </p:spPr>
-      </p:sp>
-      <p:sp>
-        <p:nvSpPr>
-          <p:cNvPr id="4" name="Shape 2"/>
-          <p:cNvSpPr/>
-          <p:nvPr/>
-        </p:nvSpPr>
-        <p:spPr>
-          <a:xfrm>
-            <a:off x="3483341" y="0"/>
-            <a:ext cx="1750815" cy="128016"/>
-          </a:xfrm>
-          <a:prstGeom prst="rect">
-            <a:avLst/>
-          </a:prstGeom>
-          <a:solidFill>
-            <a:srgbClr val="FFE066"/>
-          </a:solidFill>
-          <a:ln w="12700">
-            <a:solidFill>
-              <a:srgbClr val="FFE066"/>
-            </a:solidFill>
-            <a:prstDash val="solid"/>
-          </a:ln>
-        </p:spPr>
-      </p:sp>
-      <p:sp>
-        <p:nvSpPr>
-          <p:cNvPr id="5" name="Shape 3"/>
-          <p:cNvSpPr/>
-          <p:nvPr/>
-        </p:nvSpPr>
-        <p:spPr>
-          <a:xfrm>
-            <a:off x="5225012" y="0"/>
-            <a:ext cx="1750815" cy="128016"/>
-          </a:xfrm>
-          <a:prstGeom prst="rect">
-            <a:avLst/>
-          </a:prstGeom>
-          <a:solidFill>
-            <a:srgbClr val="8CE99A"/>
-          </a:solidFill>
-          <a:ln w="12700">
-            <a:solidFill>
-              <a:srgbClr val="8CE99A"/>
-            </a:solidFill>
-            <a:prstDash val="solid"/>
-          </a:ln>
-        </p:spPr>
-      </p:sp>
-      <p:sp>
-        <p:nvSpPr>
-          <p:cNvPr id="6" name="Shape 4"/>
-          <p:cNvSpPr/>
-          <p:nvPr/>
-        </p:nvSpPr>
-        <p:spPr>
-          <a:xfrm>
-            <a:off x="6966683" y="0"/>
-            <a:ext cx="1750815" cy="128016"/>
-          </a:xfrm>
-          <a:prstGeom prst="rect">
-            <a:avLst/>
-          </a:prstGeom>
-          <a:solidFill>
-            <a:srgbClr val="66D9E8"/>
-          </a:solidFill>
-          <a:ln w="12700">
-            <a:solidFill>
-              <a:srgbClr val="66D9E8"/>
-            </a:solidFill>
-            <a:prstDash val="solid"/>
-          </a:ln>
-        </p:spPr>
-      </p:sp>
-      <p:sp>
-        <p:nvSpPr>
-          <p:cNvPr id="7" name="Shape 5"/>
-          <p:cNvSpPr/>
-          <p:nvPr/>
-        </p:nvSpPr>
-        <p:spPr>
-          <a:xfrm>
-            <a:off x="8708354" y="0"/>
-            <a:ext cx="1750815" cy="128016"/>
-          </a:xfrm>
-          <a:prstGeom prst="rect">
-            <a:avLst/>
-          </a:prstGeom>
-          <a:solidFill>
-            <a:srgbClr val="74C0FC"/>
-          </a:solidFill>
-          <a:ln w="12700">
-            <a:solidFill>
-              <a:srgbClr val="74C0FC"/>
-            </a:solidFill>
-            <a:prstDash val="solid"/>
-          </a:ln>
-        </p:spPr>
-      </p:sp>
-      <p:sp>
-        <p:nvSpPr>
-          <p:cNvPr id="8" name="Shape 6"/>
-          <p:cNvSpPr/>
-          <p:nvPr/>
-        </p:nvSpPr>
-        <p:spPr>
-          <a:xfrm>
-            <a:off x="10450024" y="0"/>
-            <a:ext cx="1750815" cy="128016"/>
-          </a:xfrm>
-          <a:prstGeom prst="rect">
-            <a:avLst/>
-          </a:prstGeom>
-          <a:solidFill>
-            <a:srgbClr val="B197FC"/>
-          </a:solidFill>
-          <a:ln w="12700">
-            <a:solidFill>
-              <a:srgbClr val="B197FC"/>
-            </a:solidFill>
-            <a:prstDash val="solid"/>
-          </a:ln>
-        </p:spPr>
-      </p:sp>
-      <p:sp>
-        <p:nvSpPr>
-          <p:cNvPr id="9" name="Text 7"/>
+          <p:cNvPr id="3" name="Text 1"/>
           <p:cNvSpPr/>
           <p:nvPr/>
         </p:nvSpPr>
@@ -24808,7 +23758,7 @@
       </p:sp>
       <p:sp>
         <p:nvSpPr>
-          <p:cNvPr id="10" name="Text 8"/>
+          <p:cNvPr id="4" name="Text 2"/>
           <p:cNvSpPr/>
           <p:nvPr/>
         </p:nvSpPr>
@@ -27456,17 +26406,17 @@
         <p:spPr>
           <a:xfrm>
             <a:off x="0" y="0"/>
-            <a:ext cx="1750815" cy="128016"/>
+            <a:ext cx="12191695" cy="128016"/>
           </a:xfrm>
           <a:prstGeom prst="rect">
             <a:avLst/>
           </a:prstGeom>
           <a:solidFill>
-            <a:srgbClr val="FF6B6B"/>
+            <a:srgbClr val="6CC3FF"/>
           </a:solidFill>
           <a:ln w="12700">
             <a:solidFill>
-              <a:srgbClr val="FF6B6B"/>
+              <a:srgbClr val="6CC3FF"/>
             </a:solidFill>
             <a:prstDash val="solid"/>
           </a:ln>
@@ -27474,157 +26424,7 @@
       </p:sp>
       <p:sp>
         <p:nvSpPr>
-          <p:cNvPr id="3" name="Shape 1"/>
-          <p:cNvSpPr/>
-          <p:nvPr/>
-        </p:nvSpPr>
-        <p:spPr>
-          <a:xfrm>
-            <a:off x="1741671" y="0"/>
-            <a:ext cx="1750815" cy="128016"/>
-          </a:xfrm>
-          <a:prstGeom prst="rect">
-            <a:avLst/>
-          </a:prstGeom>
-          <a:solidFill>
-            <a:srgbClr val="FFA94D"/>
-          </a:solidFill>
-          <a:ln w="12700">
-            <a:solidFill>
-              <a:srgbClr val="FFA94D"/>
-            </a:solidFill>
-            <a:prstDash val="solid"/>
-          </a:ln>
-        </p:spPr>
-      </p:sp>
-      <p:sp>
-        <p:nvSpPr>
-          <p:cNvPr id="4" name="Shape 2"/>
-          <p:cNvSpPr/>
-          <p:nvPr/>
-        </p:nvSpPr>
-        <p:spPr>
-          <a:xfrm>
-            <a:off x="3483341" y="0"/>
-            <a:ext cx="1750815" cy="128016"/>
-          </a:xfrm>
-          <a:prstGeom prst="rect">
-            <a:avLst/>
-          </a:prstGeom>
-          <a:solidFill>
-            <a:srgbClr val="FFE066"/>
-          </a:solidFill>
-          <a:ln w="12700">
-            <a:solidFill>
-              <a:srgbClr val="FFE066"/>
-            </a:solidFill>
-            <a:prstDash val="solid"/>
-          </a:ln>
-        </p:spPr>
-      </p:sp>
-      <p:sp>
-        <p:nvSpPr>
-          <p:cNvPr id="5" name="Shape 3"/>
-          <p:cNvSpPr/>
-          <p:nvPr/>
-        </p:nvSpPr>
-        <p:spPr>
-          <a:xfrm>
-            <a:off x="5225012" y="0"/>
-            <a:ext cx="1750815" cy="128016"/>
-          </a:xfrm>
-          <a:prstGeom prst="rect">
-            <a:avLst/>
-          </a:prstGeom>
-          <a:solidFill>
-            <a:srgbClr val="8CE99A"/>
-          </a:solidFill>
-          <a:ln w="12700">
-            <a:solidFill>
-              <a:srgbClr val="8CE99A"/>
-            </a:solidFill>
-            <a:prstDash val="solid"/>
-          </a:ln>
-        </p:spPr>
-      </p:sp>
-      <p:sp>
-        <p:nvSpPr>
-          <p:cNvPr id="6" name="Shape 4"/>
-          <p:cNvSpPr/>
-          <p:nvPr/>
-        </p:nvSpPr>
-        <p:spPr>
-          <a:xfrm>
-            <a:off x="6966683" y="0"/>
-            <a:ext cx="1750815" cy="128016"/>
-          </a:xfrm>
-          <a:prstGeom prst="rect">
-            <a:avLst/>
-          </a:prstGeom>
-          <a:solidFill>
-            <a:srgbClr val="66D9E8"/>
-          </a:solidFill>
-          <a:ln w="12700">
-            <a:solidFill>
-              <a:srgbClr val="66D9E8"/>
-            </a:solidFill>
-            <a:prstDash val="solid"/>
-          </a:ln>
-        </p:spPr>
-      </p:sp>
-      <p:sp>
-        <p:nvSpPr>
-          <p:cNvPr id="7" name="Shape 5"/>
-          <p:cNvSpPr/>
-          <p:nvPr/>
-        </p:nvSpPr>
-        <p:spPr>
-          <a:xfrm>
-            <a:off x="8708354" y="0"/>
-            <a:ext cx="1750815" cy="128016"/>
-          </a:xfrm>
-          <a:prstGeom prst="rect">
-            <a:avLst/>
-          </a:prstGeom>
-          <a:solidFill>
-            <a:srgbClr val="74C0FC"/>
-          </a:solidFill>
-          <a:ln w="12700">
-            <a:solidFill>
-              <a:srgbClr val="74C0FC"/>
-            </a:solidFill>
-            <a:prstDash val="solid"/>
-          </a:ln>
-        </p:spPr>
-      </p:sp>
-      <p:sp>
-        <p:nvSpPr>
-          <p:cNvPr id="8" name="Shape 6"/>
-          <p:cNvSpPr/>
-          <p:nvPr/>
-        </p:nvSpPr>
-        <p:spPr>
-          <a:xfrm>
-            <a:off x="10450024" y="0"/>
-            <a:ext cx="1750815" cy="128016"/>
-          </a:xfrm>
-          <a:prstGeom prst="rect">
-            <a:avLst/>
-          </a:prstGeom>
-          <a:solidFill>
-            <a:srgbClr val="B197FC"/>
-          </a:solidFill>
-          <a:ln w="12700">
-            <a:solidFill>
-              <a:srgbClr val="B197FC"/>
-            </a:solidFill>
-            <a:prstDash val="solid"/>
-          </a:ln>
-        </p:spPr>
-      </p:sp>
-      <p:sp>
-        <p:nvSpPr>
-          <p:cNvPr id="9" name="Text 7"/>
+          <p:cNvPr id="3" name="Text 1"/>
           <p:cNvSpPr/>
           <p:nvPr/>
         </p:nvSpPr>
@@ -27663,7 +26463,7 @@
       </p:sp>
       <p:sp>
         <p:nvSpPr>
-          <p:cNvPr id="10" name="Text 8"/>
+          <p:cNvPr id="4" name="Text 2"/>
           <p:cNvSpPr/>
           <p:nvPr/>
         </p:nvSpPr>
@@ -27704,7 +26504,7 @@
       </p:sp>
       <p:sp>
         <p:nvSpPr>
-          <p:cNvPr id="11" name="Text 9"/>
+          <p:cNvPr id="5" name="Text 3"/>
           <p:cNvSpPr/>
           <p:nvPr/>
         </p:nvSpPr>

</xml_diff>

<commit_message>
docs(site): publish discovery-plan follow-along updates and regenerated deck
</commit_message>
<xml_diff>
--- a/presentation/Azure_Local_Discovery_to_Day2_NIC2026.pptx
+++ b/presentation/Azure_Local_Discovery_to_Day2_NIC2026.pptx
@@ -3711,7 +3711,7 @@
             <a:pPr/>
             <a:r>
               <a:rPr lang="en-US" sz="2000" dirty="0"/>
-              <a:t>Building the ship: foundation, site readiness, machine provisioning</a:t>
+              <a:t>Building the ship: foundation, WinPE evidence and OS-disk handoff</a:t>
             </a:r>
           </a:p>
         </p:txBody>
@@ -3825,336 +3825,99 @@
           <a:p>
             <a:pPr algn="ctr"/>
             <a:r>
-              <a:rPr lang="en-US" sz="1300" i="1" dirty="0">
+              <a:rPr lang="en-US" sz="1000" i="1" dirty="0">
                 <a:solidFill>
                   <a:srgbClr val="C3FBFE"/>
                 </a:solidFill>
                 <a:latin typeface="Roboto"/>
                 <a:cs typeface="Roboto"/>
               </a:rPr>
-              <a:t>The landing zone as Bicep, idempotent.</a:t>
-            </a:r>
-          </a:p>
-        </p:txBody>
-      </p:sp>
-      <p:sp>
-        <p:nvSpPr>
-          <p:cNvPr id="6" name="Card 6"/>
-          <p:cNvSpPr/>
-          <p:nvPr/>
-        </p:nvSpPr>
-        <p:spPr>
-          <a:xfrm>
-            <a:off x="457200" y="1975104"/>
-            <a:ext cx="2621280" cy="1920240"/>
-          </a:xfrm>
-          <a:prstGeom prst="roundRect">
-            <a:avLst>
-              <a:gd name="adj" fmla="val 6000"/>
-            </a:avLst>
-          </a:prstGeom>
-          <a:solidFill>
-            <a:srgbClr val="262929"/>
-          </a:solidFill>
-          <a:ln w="19050">
-            <a:solidFill>
-              <a:srgbClr val="98F8FE"/>
-            </a:solidFill>
-          </a:ln>
-        </p:spPr>
-        <p:txBody>
-          <a:bodyPr rtlCol="0" anchor="ctr"/>
-          <a:lstStyle/>
-          <a:p>
-            <a:endParaRPr lang="en-US" dirty="0"/>
-          </a:p>
-        </p:txBody>
-      </p:sp>
-      <p:sp>
-        <p:nvSpPr>
-          <p:cNvPr id="7" name="Rule 7"/>
-          <p:cNvSpPr/>
-          <p:nvPr/>
-        </p:nvSpPr>
-        <p:spPr>
-          <a:xfrm>
-            <a:off x="621792" y="2157984"/>
-            <a:ext cx="457200" cy="64008"/>
-          </a:xfrm>
-          <a:prstGeom prst="rect">
-            <a:avLst/>
-          </a:prstGeom>
-          <a:solidFill>
-            <a:srgbClr val="FDBA12"/>
-          </a:solidFill>
-          <a:ln>
-            <a:noFill/>
-          </a:ln>
-        </p:spPr>
-        <p:txBody>
-          <a:bodyPr rtlCol="0" anchor="ctr"/>
-          <a:lstStyle/>
-          <a:p>
-            <a:endParaRPr lang="en-US" dirty="0"/>
-          </a:p>
-        </p:txBody>
-      </p:sp>
-      <p:sp>
-        <p:nvSpPr>
-          <p:cNvPr id="8" name="Text 8"/>
-          <p:cNvSpPr txBox="1"/>
-          <p:nvPr/>
-        </p:nvSpPr>
-        <p:spPr>
-          <a:xfrm>
-            <a:off x="548640" y="2295144"/>
-            <a:ext cx="2438400" cy="1508760"/>
-          </a:xfrm>
-          <a:prstGeom prst="rect">
-            <a:avLst/>
-          </a:prstGeom>
-          <a:noFill/>
-          <a:ln>
-            <a:noFill/>
-          </a:ln>
-        </p:spPr>
-        <p:txBody>
-          <a:bodyPr wrap="square" lIns="73152" tIns="36576" rIns="73152" bIns="36576" rtlCol="0" anchor="t">
-            <a:noAutofit/>
+              <a:t>The foundation and site checks lead to a non-destructive WinPE evidence gate; deterministic OS-disk identity is required before...</a:t>
+            </a:r>
+          </a:p>
+        </p:txBody>
+      </p:sp>
+      <p:sp>
+        <p:nvSpPr>
+          <p:cNvPr id="6" name="Content 6"/>
+          <p:cNvSpPr>
+            <a:spLocks noGrp="1"/>
+          </p:cNvSpPr>
+          <p:nvPr>
+            <p:ph type="body" sz="quarter" idx="10"/>
+          </p:nvPr>
+        </p:nvSpPr>
+        <p:spPr>
+          <a:xfrm>
+            <a:off x="457200" y="1517904"/>
+            <a:ext cx="8229600" cy="2926080"/>
+          </a:xfrm>
+        </p:spPr>
+        <p:txBody>
+          <a:bodyPr anchor="t">
+            <a:normAutofit/>
           </a:bodyPr>
           <a:lstStyle/>
           <a:p>
             <a:pPr>
               <a:spcBef>
-                <a:spcPts val="0"/>
+                <a:spcPts val="700"/>
               </a:spcBef>
             </a:pPr>
             <a:r>
-              <a:rPr lang="en-US" sz="1600" dirty="0">
-                <a:solidFill>
-                  <a:srgbClr val="98F8FE"/>
-                </a:solidFill>
-                <a:latin typeface="Roboto"/>
-                <a:cs typeface="Roboto"/>
-              </a:rPr>
+              <a:rPr lang="en-US" sz="1700" dirty="0"/>
               <a:t>Resource groups, providers, workspace, Key Vault, witness, spoke, tags, budgets</a:t>
             </a:r>
           </a:p>
-        </p:txBody>
-      </p:sp>
-      <p:sp>
-        <p:nvSpPr>
-          <p:cNvPr id="9" name="Card 9"/>
-          <p:cNvSpPr/>
-          <p:nvPr/>
-        </p:nvSpPr>
-        <p:spPr>
-          <a:xfrm>
-            <a:off x="3261360" y="1975104"/>
-            <a:ext cx="2621280" cy="1920240"/>
-          </a:xfrm>
-          <a:prstGeom prst="roundRect">
-            <a:avLst>
-              <a:gd name="adj" fmla="val 6000"/>
-            </a:avLst>
-          </a:prstGeom>
-          <a:solidFill>
-            <a:srgbClr val="262929"/>
-          </a:solidFill>
-          <a:ln w="19050">
-            <a:solidFill>
-              <a:srgbClr val="98F8FE"/>
-            </a:solidFill>
-          </a:ln>
-        </p:spPr>
-        <p:txBody>
-          <a:bodyPr rtlCol="0" anchor="ctr"/>
-          <a:lstStyle/>
-          <a:p>
-            <a:endParaRPr lang="en-US" dirty="0"/>
-          </a:p>
-        </p:txBody>
-      </p:sp>
-      <p:sp>
-        <p:nvSpPr>
-          <p:cNvPr id="10" name="Rule 10"/>
-          <p:cNvSpPr/>
-          <p:nvPr/>
-        </p:nvSpPr>
-        <p:spPr>
-          <a:xfrm>
-            <a:off x="3425952" y="2157984"/>
-            <a:ext cx="457200" cy="64008"/>
-          </a:xfrm>
-          <a:prstGeom prst="rect">
-            <a:avLst/>
-          </a:prstGeom>
-          <a:solidFill>
-            <a:srgbClr val="FDBA12"/>
-          </a:solidFill>
-          <a:ln>
-            <a:noFill/>
-          </a:ln>
-        </p:spPr>
-        <p:txBody>
-          <a:bodyPr rtlCol="0" anchor="ctr"/>
-          <a:lstStyle/>
-          <a:p>
-            <a:endParaRPr lang="en-US" dirty="0"/>
-          </a:p>
-        </p:txBody>
-      </p:sp>
-      <p:sp>
-        <p:nvSpPr>
-          <p:cNvPr id="11" name="Text 11"/>
-          <p:cNvSpPr txBox="1"/>
-          <p:nvPr/>
-        </p:nvSpPr>
-        <p:spPr>
-          <a:xfrm>
-            <a:off x="3352800" y="2295144"/>
-            <a:ext cx="2438400" cy="1508760"/>
-          </a:xfrm>
-          <a:prstGeom prst="rect">
-            <a:avLst/>
-          </a:prstGeom>
-          <a:noFill/>
-          <a:ln>
-            <a:noFill/>
-          </a:ln>
-        </p:spPr>
-        <p:txBody>
-          <a:bodyPr wrap="square" lIns="73152" tIns="36576" rIns="73152" bIns="36576" rtlCol="0" anchor="t">
-            <a:noAutofit/>
-          </a:bodyPr>
-          <a:lstStyle/>
           <a:p>
             <a:pPr>
               <a:spcBef>
-                <a:spcPts val="0"/>
+                <a:spcPts val="700"/>
               </a:spcBef>
             </a:pPr>
             <a:r>
-              <a:rPr lang="en-US" sz="1600" dirty="0">
-                <a:solidFill>
-                  <a:srgbClr val="98F8FE"/>
-                </a:solidFill>
-                <a:latin typeface="Roboto"/>
-                <a:cs typeface="Roboto"/>
-              </a:rPr>
+              <a:rPr lang="en-US" sz="1700" dirty="0"/>
               <a:t>Environment Checker before anyone registers a node</a:t>
             </a:r>
           </a:p>
-        </p:txBody>
-      </p:sp>
-      <p:sp>
-        <p:nvSpPr>
-          <p:cNvPr id="12" name="Card 12"/>
-          <p:cNvSpPr/>
-          <p:nvPr/>
-        </p:nvSpPr>
-        <p:spPr>
-          <a:xfrm>
-            <a:off x="6065520" y="1975104"/>
-            <a:ext cx="2621280" cy="1920240"/>
-          </a:xfrm>
-          <a:prstGeom prst="roundRect">
-            <a:avLst>
-              <a:gd name="adj" fmla="val 6000"/>
-            </a:avLst>
-          </a:prstGeom>
-          <a:solidFill>
-            <a:srgbClr val="262929"/>
-          </a:solidFill>
-          <a:ln w="19050">
-            <a:solidFill>
-              <a:srgbClr val="98F8FE"/>
-            </a:solidFill>
-          </a:ln>
-        </p:spPr>
-        <p:txBody>
-          <a:bodyPr rtlCol="0" anchor="ctr"/>
-          <a:lstStyle/>
-          <a:p>
-            <a:endParaRPr lang="en-US" dirty="0"/>
-          </a:p>
-        </p:txBody>
-      </p:sp>
-      <p:sp>
-        <p:nvSpPr>
-          <p:cNvPr id="13" name="Rule 13"/>
-          <p:cNvSpPr/>
-          <p:nvPr/>
-        </p:nvSpPr>
-        <p:spPr>
-          <a:xfrm>
-            <a:off x="6230112" y="2157984"/>
-            <a:ext cx="457200" cy="64008"/>
-          </a:xfrm>
-          <a:prstGeom prst="rect">
-            <a:avLst/>
-          </a:prstGeom>
-          <a:solidFill>
-            <a:srgbClr val="FDBA12"/>
-          </a:solidFill>
-          <a:ln>
-            <a:noFill/>
-          </a:ln>
-        </p:spPr>
-        <p:txBody>
-          <a:bodyPr rtlCol="0" anchor="ctr"/>
-          <a:lstStyle/>
-          <a:p>
-            <a:endParaRPr lang="en-US" dirty="0"/>
-          </a:p>
-        </p:txBody>
-      </p:sp>
-      <p:sp>
-        <p:nvSpPr>
-          <p:cNvPr id="14" name="Text 14"/>
-          <p:cNvSpPr txBox="1"/>
-          <p:nvPr/>
-        </p:nvSpPr>
-        <p:spPr>
-          <a:xfrm>
-            <a:off x="6156960" y="2295144"/>
-            <a:ext cx="2438400" cy="1508760"/>
-          </a:xfrm>
-          <a:prstGeom prst="rect">
-            <a:avLst/>
-          </a:prstGeom>
-          <a:noFill/>
-          <a:ln>
-            <a:noFill/>
-          </a:ln>
-        </p:spPr>
-        <p:txBody>
-          <a:bodyPr wrap="square" lIns="73152" tIns="36576" rIns="73152" bIns="36576" rtlCol="0" anchor="t">
-            <a:noAutofit/>
-          </a:bodyPr>
-          <a:lstStyle/>
           <a:p>
             <a:pPr>
               <a:spcBef>
-                <a:spcPts val="0"/>
+                <a:spcPts val="700"/>
               </a:spcBef>
             </a:pPr>
             <a:r>
-              <a:rPr lang="en-US" sz="1600" dirty="0">
-                <a:solidFill>
-                  <a:srgbClr val="98F8FE"/>
-                </a:solidFill>
-                <a:latin typeface="Roboto"/>
-                <a:cs typeface="Roboto"/>
-              </a:rPr>
-              <a:t>Preview alternative. This hardware is outside the supported list. Not the recommendation.</a:t>
+              <a:rPr lang="en-US" sz="1700" dirty="0"/>
+              <a:t>WinPE: confirm tool/support, tested paths and approved Azure Storage evidence upload</a:t>
+            </a:r>
+          </a:p>
+          <a:p>
+            <a:pPr>
+              <a:spcBef>
+                <a:spcPts val="700"/>
+              </a:spcBef>
+            </a:pPr>
+            <a:r>
+              <a:rPr lang="en-US" sz="1700" dirty="0"/>
+              <a:t>OS disk: node identity, serial/unique ID and controller/location; ambiguity stops provisioning</a:t>
+            </a:r>
+          </a:p>
+          <a:p>
+            <a:pPr>
+              <a:spcBef>
+                <a:spcPts val="700"/>
+              </a:spcBef>
+            </a:pPr>
+            <a:r>
+              <a:rPr lang="en-US" sz="1700" dirty="0"/>
+              <a:t>Tool/runtime evidence pending T-7.1.9; simplified provisioning is a separate preview alternative</a:t>
             </a:r>
           </a:p>
         </p:txBody>
       </p:sp>
       <p:cxnSp>
         <p:nvCxnSpPr>
-          <p:cNvPr id="15" name="Line 15"/>
+          <p:cNvPr id="7" name="Line 7"/>
           <p:cNvCxnSpPr/>
           <p:nvPr/>
         </p:nvCxnSpPr>
@@ -4175,13 +3938,285 @@
       </p:cxnSp>
       <p:sp>
         <p:nvSpPr>
+          <p:cNvPr id="8" name="Node 8"/>
+          <p:cNvSpPr/>
+          <p:nvPr/>
+        </p:nvSpPr>
+        <p:spPr>
+          <a:xfrm>
+            <a:off x="2976372" y="4832604"/>
+            <a:ext cx="82296" cy="82296"/>
+          </a:xfrm>
+          <a:prstGeom prst="ellipse">
+            <a:avLst/>
+          </a:prstGeom>
+          <a:solidFill>
+            <a:srgbClr val="4B6B6D"/>
+          </a:solidFill>
+          <a:ln>
+            <a:noFill/>
+          </a:ln>
+        </p:spPr>
+        <p:txBody>
+          <a:bodyPr rtlCol="0" anchor="ctr"/>
+          <a:lstStyle/>
+          <a:p>
+            <a:endParaRPr lang="en-US" dirty="0"/>
+          </a:p>
+        </p:txBody>
+      </p:sp>
+      <p:sp>
+        <p:nvSpPr>
+          <p:cNvPr id="9" name="Text 9"/>
+          <p:cNvSpPr txBox="1"/>
+          <p:nvPr/>
+        </p:nvSpPr>
+        <p:spPr>
+          <a:xfrm>
+            <a:off x="2560320" y="4626864"/>
+            <a:ext cx="914400" cy="155448"/>
+          </a:xfrm>
+          <a:prstGeom prst="rect">
+            <a:avLst/>
+          </a:prstGeom>
+          <a:noFill/>
+          <a:ln>
+            <a:noFill/>
+          </a:ln>
+        </p:spPr>
+        <p:txBody>
+          <a:bodyPr wrap="square" lIns="0" tIns="0" rIns="0" bIns="0" rtlCol="0" anchor="ctr">
+            <a:noAutofit/>
+          </a:bodyPr>
+          <a:lstStyle/>
+          <a:p>
+            <a:pPr algn="ctr"/>
+            <a:r>
+              <a:rPr lang="en-US" sz="700" dirty="0">
+                <a:solidFill>
+                  <a:srgbClr val="A9D3D6"/>
+                </a:solidFill>
+                <a:latin typeface="Roboto"/>
+                <a:cs typeface="Roboto"/>
+              </a:rPr>
+              <a:t>Chart</a:t>
+            </a:r>
+          </a:p>
+        </p:txBody>
+      </p:sp>
+      <p:sp>
+        <p:nvSpPr>
+          <p:cNvPr id="10" name="Node 10"/>
+          <p:cNvSpPr/>
+          <p:nvPr/>
+        </p:nvSpPr>
+        <p:spPr>
+          <a:xfrm>
+            <a:off x="3899916" y="4805172"/>
+            <a:ext cx="137160" cy="137160"/>
+          </a:xfrm>
+          <a:prstGeom prst="ellipse">
+            <a:avLst/>
+          </a:prstGeom>
+          <a:solidFill>
+            <a:srgbClr val="FDBA12"/>
+          </a:solidFill>
+          <a:ln>
+            <a:noFill/>
+          </a:ln>
+        </p:spPr>
+        <p:txBody>
+          <a:bodyPr rtlCol="0" anchor="ctr"/>
+          <a:lstStyle/>
+          <a:p>
+            <a:endParaRPr lang="en-US" dirty="0"/>
+          </a:p>
+        </p:txBody>
+      </p:sp>
+      <p:sp>
+        <p:nvSpPr>
+          <p:cNvPr id="11" name="Text 11"/>
+          <p:cNvSpPr txBox="1"/>
+          <p:nvPr/>
+        </p:nvSpPr>
+        <p:spPr>
+          <a:xfrm>
+            <a:off x="3511296" y="4626864"/>
+            <a:ext cx="914400" cy="155448"/>
+          </a:xfrm>
+          <a:prstGeom prst="rect">
+            <a:avLst/>
+          </a:prstGeom>
+          <a:noFill/>
+          <a:ln>
+            <a:noFill/>
+          </a:ln>
+        </p:spPr>
+        <p:txBody>
+          <a:bodyPr wrap="square" lIns="0" tIns="0" rIns="0" bIns="0" rtlCol="0" anchor="ctr">
+            <a:noAutofit/>
+          </a:bodyPr>
+          <a:lstStyle/>
+          <a:p>
+            <a:pPr algn="ctr"/>
+            <a:r>
+              <a:rPr lang="en-US" sz="700" b="1" dirty="0">
+                <a:solidFill>
+                  <a:srgbClr val="98F8FE"/>
+                </a:solidFill>
+                <a:latin typeface="Roboto"/>
+                <a:cs typeface="Roboto"/>
+              </a:rPr>
+              <a:t>Build</a:t>
+            </a:r>
+          </a:p>
+        </p:txBody>
+      </p:sp>
+      <p:sp>
+        <p:nvSpPr>
+          <p:cNvPr id="12" name="Node 12"/>
+          <p:cNvSpPr/>
+          <p:nvPr/>
+        </p:nvSpPr>
+        <p:spPr>
+          <a:xfrm>
+            <a:off x="4878324" y="4832604"/>
+            <a:ext cx="82296" cy="82296"/>
+          </a:xfrm>
+          <a:prstGeom prst="ellipse">
+            <a:avLst/>
+          </a:prstGeom>
+          <a:solidFill>
+            <a:srgbClr val="4B6B6D"/>
+          </a:solidFill>
+          <a:ln>
+            <a:noFill/>
+          </a:ln>
+        </p:spPr>
+        <p:txBody>
+          <a:bodyPr rtlCol="0" anchor="ctr"/>
+          <a:lstStyle/>
+          <a:p>
+            <a:endParaRPr lang="en-US" dirty="0"/>
+          </a:p>
+        </p:txBody>
+      </p:sp>
+      <p:sp>
+        <p:nvSpPr>
+          <p:cNvPr id="13" name="Text 13"/>
+          <p:cNvSpPr txBox="1"/>
+          <p:nvPr/>
+        </p:nvSpPr>
+        <p:spPr>
+          <a:xfrm>
+            <a:off x="4462272" y="4626864"/>
+            <a:ext cx="914400" cy="155448"/>
+          </a:xfrm>
+          <a:prstGeom prst="rect">
+            <a:avLst/>
+          </a:prstGeom>
+          <a:noFill/>
+          <a:ln>
+            <a:noFill/>
+          </a:ln>
+        </p:spPr>
+        <p:txBody>
+          <a:bodyPr wrap="square" lIns="0" tIns="0" rIns="0" bIns="0" rtlCol="0" anchor="ctr">
+            <a:noAutofit/>
+          </a:bodyPr>
+          <a:lstStyle/>
+          <a:p>
+            <a:pPr algn="ctr"/>
+            <a:r>
+              <a:rPr lang="en-US" sz="700" dirty="0">
+                <a:solidFill>
+                  <a:srgbClr val="A9D3D6"/>
+                </a:solidFill>
+                <a:latin typeface="Roboto"/>
+                <a:cs typeface="Roboto"/>
+              </a:rPr>
+              <a:t>Seaworthy</a:t>
+            </a:r>
+          </a:p>
+        </p:txBody>
+      </p:sp>
+      <p:sp>
+        <p:nvSpPr>
+          <p:cNvPr id="14" name="Node 14"/>
+          <p:cNvSpPr/>
+          <p:nvPr/>
+        </p:nvSpPr>
+        <p:spPr>
+          <a:xfrm>
+            <a:off x="5829300" y="4832604"/>
+            <a:ext cx="82296" cy="82296"/>
+          </a:xfrm>
+          <a:prstGeom prst="ellipse">
+            <a:avLst/>
+          </a:prstGeom>
+          <a:solidFill>
+            <a:srgbClr val="4B6B6D"/>
+          </a:solidFill>
+          <a:ln>
+            <a:noFill/>
+          </a:ln>
+        </p:spPr>
+        <p:txBody>
+          <a:bodyPr rtlCol="0" anchor="ctr"/>
+          <a:lstStyle/>
+          <a:p>
+            <a:endParaRPr lang="en-US" dirty="0"/>
+          </a:p>
+        </p:txBody>
+      </p:sp>
+      <p:sp>
+        <p:nvSpPr>
+          <p:cNvPr id="15" name="Text 15"/>
+          <p:cNvSpPr txBox="1"/>
+          <p:nvPr/>
+        </p:nvSpPr>
+        <p:spPr>
+          <a:xfrm>
+            <a:off x="5413248" y="4626864"/>
+            <a:ext cx="914400" cy="155448"/>
+          </a:xfrm>
+          <a:prstGeom prst="rect">
+            <a:avLst/>
+          </a:prstGeom>
+          <a:noFill/>
+          <a:ln>
+            <a:noFill/>
+          </a:ln>
+        </p:spPr>
+        <p:txBody>
+          <a:bodyPr wrap="square" lIns="0" tIns="0" rIns="0" bIns="0" rtlCol="0" anchor="ctr">
+            <a:noAutofit/>
+          </a:bodyPr>
+          <a:lstStyle/>
+          <a:p>
+            <a:pPr algn="ctr"/>
+            <a:r>
+              <a:rPr lang="en-US" sz="700" dirty="0">
+                <a:solidFill>
+                  <a:srgbClr val="A9D3D6"/>
+                </a:solidFill>
+                <a:latin typeface="Roboto"/>
+                <a:cs typeface="Roboto"/>
+              </a:rPr>
+              <a:t>Cargo</a:t>
+            </a:r>
+          </a:p>
+        </p:txBody>
+      </p:sp>
+      <p:sp>
+        <p:nvSpPr>
           <p:cNvPr id="16" name="Node 16"/>
           <p:cNvSpPr/>
           <p:nvPr/>
         </p:nvSpPr>
         <p:spPr>
           <a:xfrm>
-            <a:off x="2976372" y="4832604"/>
+            <a:off x="6780276" y="4832604"/>
             <a:ext cx="82296" cy="82296"/>
           </a:xfrm>
           <a:prstGeom prst="ellipse">
@@ -4210,7 +4245,7 @@
         </p:nvSpPr>
         <p:spPr>
           <a:xfrm>
-            <a:off x="2560320" y="4626864"/>
+            <a:off x="6364224" y="4626864"/>
             <a:ext cx="914400" cy="155448"/>
           </a:xfrm>
           <a:prstGeom prst="rect">
@@ -4236,7 +4271,7 @@
                 <a:latin typeface="Roboto"/>
                 <a:cs typeface="Roboto"/>
               </a:rPr>
-              <a:t>Chart</a:t>
+              <a:t>Storm</a:t>
             </a:r>
           </a:p>
         </p:txBody>
@@ -4249,278 +4284,6 @@
         </p:nvSpPr>
         <p:spPr>
           <a:xfrm>
-            <a:off x="3899916" y="4805172"/>
-            <a:ext cx="137160" cy="137160"/>
-          </a:xfrm>
-          <a:prstGeom prst="ellipse">
-            <a:avLst/>
-          </a:prstGeom>
-          <a:solidFill>
-            <a:srgbClr val="FDBA12"/>
-          </a:solidFill>
-          <a:ln>
-            <a:noFill/>
-          </a:ln>
-        </p:spPr>
-        <p:txBody>
-          <a:bodyPr rtlCol="0" anchor="ctr"/>
-          <a:lstStyle/>
-          <a:p>
-            <a:endParaRPr lang="en-US" dirty="0"/>
-          </a:p>
-        </p:txBody>
-      </p:sp>
-      <p:sp>
-        <p:nvSpPr>
-          <p:cNvPr id="19" name="Text 19"/>
-          <p:cNvSpPr txBox="1"/>
-          <p:nvPr/>
-        </p:nvSpPr>
-        <p:spPr>
-          <a:xfrm>
-            <a:off x="3511296" y="4626864"/>
-            <a:ext cx="914400" cy="155448"/>
-          </a:xfrm>
-          <a:prstGeom prst="rect">
-            <a:avLst/>
-          </a:prstGeom>
-          <a:noFill/>
-          <a:ln>
-            <a:noFill/>
-          </a:ln>
-        </p:spPr>
-        <p:txBody>
-          <a:bodyPr wrap="square" lIns="0" tIns="0" rIns="0" bIns="0" rtlCol="0" anchor="ctr">
-            <a:noAutofit/>
-          </a:bodyPr>
-          <a:lstStyle/>
-          <a:p>
-            <a:pPr algn="ctr"/>
-            <a:r>
-              <a:rPr lang="en-US" sz="700" b="1" dirty="0">
-                <a:solidFill>
-                  <a:srgbClr val="98F8FE"/>
-                </a:solidFill>
-                <a:latin typeface="Roboto"/>
-                <a:cs typeface="Roboto"/>
-              </a:rPr>
-              <a:t>Build</a:t>
-            </a:r>
-          </a:p>
-        </p:txBody>
-      </p:sp>
-      <p:sp>
-        <p:nvSpPr>
-          <p:cNvPr id="20" name="Node 20"/>
-          <p:cNvSpPr/>
-          <p:nvPr/>
-        </p:nvSpPr>
-        <p:spPr>
-          <a:xfrm>
-            <a:off x="4878324" y="4832604"/>
-            <a:ext cx="82296" cy="82296"/>
-          </a:xfrm>
-          <a:prstGeom prst="ellipse">
-            <a:avLst/>
-          </a:prstGeom>
-          <a:solidFill>
-            <a:srgbClr val="4B6B6D"/>
-          </a:solidFill>
-          <a:ln>
-            <a:noFill/>
-          </a:ln>
-        </p:spPr>
-        <p:txBody>
-          <a:bodyPr rtlCol="0" anchor="ctr"/>
-          <a:lstStyle/>
-          <a:p>
-            <a:endParaRPr lang="en-US" dirty="0"/>
-          </a:p>
-        </p:txBody>
-      </p:sp>
-      <p:sp>
-        <p:nvSpPr>
-          <p:cNvPr id="21" name="Text 21"/>
-          <p:cNvSpPr txBox="1"/>
-          <p:nvPr/>
-        </p:nvSpPr>
-        <p:spPr>
-          <a:xfrm>
-            <a:off x="4462272" y="4626864"/>
-            <a:ext cx="914400" cy="155448"/>
-          </a:xfrm>
-          <a:prstGeom prst="rect">
-            <a:avLst/>
-          </a:prstGeom>
-          <a:noFill/>
-          <a:ln>
-            <a:noFill/>
-          </a:ln>
-        </p:spPr>
-        <p:txBody>
-          <a:bodyPr wrap="square" lIns="0" tIns="0" rIns="0" bIns="0" rtlCol="0" anchor="ctr">
-            <a:noAutofit/>
-          </a:bodyPr>
-          <a:lstStyle/>
-          <a:p>
-            <a:pPr algn="ctr"/>
-            <a:r>
-              <a:rPr lang="en-US" sz="700" dirty="0">
-                <a:solidFill>
-                  <a:srgbClr val="A9D3D6"/>
-                </a:solidFill>
-                <a:latin typeface="Roboto"/>
-                <a:cs typeface="Roboto"/>
-              </a:rPr>
-              <a:t>Seaworthy</a:t>
-            </a:r>
-          </a:p>
-        </p:txBody>
-      </p:sp>
-      <p:sp>
-        <p:nvSpPr>
-          <p:cNvPr id="22" name="Node 22"/>
-          <p:cNvSpPr/>
-          <p:nvPr/>
-        </p:nvSpPr>
-        <p:spPr>
-          <a:xfrm>
-            <a:off x="5829300" y="4832604"/>
-            <a:ext cx="82296" cy="82296"/>
-          </a:xfrm>
-          <a:prstGeom prst="ellipse">
-            <a:avLst/>
-          </a:prstGeom>
-          <a:solidFill>
-            <a:srgbClr val="4B6B6D"/>
-          </a:solidFill>
-          <a:ln>
-            <a:noFill/>
-          </a:ln>
-        </p:spPr>
-        <p:txBody>
-          <a:bodyPr rtlCol="0" anchor="ctr"/>
-          <a:lstStyle/>
-          <a:p>
-            <a:endParaRPr lang="en-US" dirty="0"/>
-          </a:p>
-        </p:txBody>
-      </p:sp>
-      <p:sp>
-        <p:nvSpPr>
-          <p:cNvPr id="23" name="Text 23"/>
-          <p:cNvSpPr txBox="1"/>
-          <p:nvPr/>
-        </p:nvSpPr>
-        <p:spPr>
-          <a:xfrm>
-            <a:off x="5413248" y="4626864"/>
-            <a:ext cx="914400" cy="155448"/>
-          </a:xfrm>
-          <a:prstGeom prst="rect">
-            <a:avLst/>
-          </a:prstGeom>
-          <a:noFill/>
-          <a:ln>
-            <a:noFill/>
-          </a:ln>
-        </p:spPr>
-        <p:txBody>
-          <a:bodyPr wrap="square" lIns="0" tIns="0" rIns="0" bIns="0" rtlCol="0" anchor="ctr">
-            <a:noAutofit/>
-          </a:bodyPr>
-          <a:lstStyle/>
-          <a:p>
-            <a:pPr algn="ctr"/>
-            <a:r>
-              <a:rPr lang="en-US" sz="700" dirty="0">
-                <a:solidFill>
-                  <a:srgbClr val="A9D3D6"/>
-                </a:solidFill>
-                <a:latin typeface="Roboto"/>
-                <a:cs typeface="Roboto"/>
-              </a:rPr>
-              <a:t>Cargo</a:t>
-            </a:r>
-          </a:p>
-        </p:txBody>
-      </p:sp>
-      <p:sp>
-        <p:nvSpPr>
-          <p:cNvPr id="24" name="Node 24"/>
-          <p:cNvSpPr/>
-          <p:nvPr/>
-        </p:nvSpPr>
-        <p:spPr>
-          <a:xfrm>
-            <a:off x="6780276" y="4832604"/>
-            <a:ext cx="82296" cy="82296"/>
-          </a:xfrm>
-          <a:prstGeom prst="ellipse">
-            <a:avLst/>
-          </a:prstGeom>
-          <a:solidFill>
-            <a:srgbClr val="4B6B6D"/>
-          </a:solidFill>
-          <a:ln>
-            <a:noFill/>
-          </a:ln>
-        </p:spPr>
-        <p:txBody>
-          <a:bodyPr rtlCol="0" anchor="ctr"/>
-          <a:lstStyle/>
-          <a:p>
-            <a:endParaRPr lang="en-US" dirty="0"/>
-          </a:p>
-        </p:txBody>
-      </p:sp>
-      <p:sp>
-        <p:nvSpPr>
-          <p:cNvPr id="25" name="Text 25"/>
-          <p:cNvSpPr txBox="1"/>
-          <p:nvPr/>
-        </p:nvSpPr>
-        <p:spPr>
-          <a:xfrm>
-            <a:off x="6364224" y="4626864"/>
-            <a:ext cx="914400" cy="155448"/>
-          </a:xfrm>
-          <a:prstGeom prst="rect">
-            <a:avLst/>
-          </a:prstGeom>
-          <a:noFill/>
-          <a:ln>
-            <a:noFill/>
-          </a:ln>
-        </p:spPr>
-        <p:txBody>
-          <a:bodyPr wrap="square" lIns="0" tIns="0" rIns="0" bIns="0" rtlCol="0" anchor="ctr">
-            <a:noAutofit/>
-          </a:bodyPr>
-          <a:lstStyle/>
-          <a:p>
-            <a:pPr algn="ctr"/>
-            <a:r>
-              <a:rPr lang="en-US" sz="700" dirty="0">
-                <a:solidFill>
-                  <a:srgbClr val="A9D3D6"/>
-                </a:solidFill>
-                <a:latin typeface="Roboto"/>
-                <a:cs typeface="Roboto"/>
-              </a:rPr>
-              <a:t>Storm</a:t>
-            </a:r>
-          </a:p>
-        </p:txBody>
-      </p:sp>
-      <p:sp>
-        <p:nvSpPr>
-          <p:cNvPr id="26" name="Node 26"/>
-          <p:cNvSpPr/>
-          <p:nvPr/>
-        </p:nvSpPr>
-        <p:spPr>
-          <a:xfrm>
             <a:off x="7731252" y="4832604"/>
             <a:ext cx="82296" cy="82296"/>
           </a:xfrm>
@@ -4544,7 +4307,7 @@
       </p:sp>
       <p:sp>
         <p:nvSpPr>
-          <p:cNvPr id="27" name="Text 27"/>
+          <p:cNvPr id="19" name="Text 19"/>
           <p:cNvSpPr txBox="1"/>
           <p:nvPr/>
         </p:nvSpPr>
@@ -4583,7 +4346,7 @@
       </p:sp>
       <p:sp>
         <p:nvSpPr>
-          <p:cNvPr id="28" name="Text 28"/>
+          <p:cNvPr id="20" name="Text 20"/>
           <p:cNvSpPr txBox="1"/>
           <p:nvPr/>
         </p:nvSpPr>
@@ -23322,14 +23085,14 @@
           <a:p>
             <a:pPr algn="ctr"/>
             <a:r>
-              <a:rPr lang="en-US" sz="1300" i="1" dirty="0">
+              <a:rPr lang="en-US" sz="1000" i="1" dirty="0">
                 <a:solidFill>
                   <a:srgbClr val="193233"/>
                 </a:solidFill>
                 <a:latin typeface="Roboto"/>
                 <a:cs typeface="Roboto"/>
               </a:rPr>
-              <a:t>What do we buy and who owns the firmware problem?</a:t>
+              <a:t>Existing hardware or new purchase: discover the whole site, verify support and map observed server/fabric evidence into the...</a:t>
             </a:r>
           </a:p>
         </p:txBody>
@@ -23362,7 +23125,7 @@
               </a:spcBef>
             </a:pPr>
             <a:r>
-              <a:rPr lang="en-US" sz="2200" dirty="0"/>
+              <a:rPr lang="en-US" sz="1800" dirty="0"/>
               <a:t>Decision: validated integrated system (two AX-760)</a:t>
             </a:r>
           </a:p>
@@ -23373,7 +23136,7 @@
               </a:spcBef>
             </a:pPr>
             <a:r>
-              <a:rPr lang="en-US" sz="2200" dirty="0"/>
+              <a:rPr lang="en-US" sz="1800" dirty="0"/>
               <a:t>Two-way mirror: one fault from zero redundancy</a:t>
             </a:r>
           </a:p>
@@ -23384,8 +23147,8 @@
               </a:spcBef>
             </a:pPr>
             <a:r>
-              <a:rPr lang="en-US" sz="2200" dirty="0"/>
-              <a:t>Outputs: bill of materials, firmware baseline</a:t>
+              <a:rPr lang="en-US" sz="1800" dirty="0"/>
+              <a:t>Inventory: servers, NIC ports/MACs, drives/controllers, boot media; ToR/OOB switches, firewall, uplinks</a:t>
             </a:r>
           </a:p>
           <a:p>
@@ -23395,8 +23158,8 @@
               </a:spcBef>
             </a:pPr>
             <a:r>
-              <a:rPr lang="en-US" sz="2200" dirty="0"/>
-              <a:t>Rack Aware: not chosen here, and not proven by this demo</a:t>
+              <a:rPr lang="en-US" sz="1800" dirty="0"/>
+              <a:t>Outputs: provenance, supported hardware/firmware review, approved JSON-to-YAML mapping</a:t>
             </a:r>
           </a:p>
           <a:p>
@@ -23406,7 +23169,18 @@
               </a:spcBef>
             </a:pPr>
             <a:r>
-              <a:rPr lang="en-US" sz="2200" dirty="0"/>
+              <a:rPr lang="en-US" sz="1800" dirty="0"/>
+              <a:t>Rack Aware: not chosen here, and not proven by this demo</a:t>
+            </a:r>
+          </a:p>
+          <a:p>
+            <a:pPr>
+              <a:spcBef>
+                <a:spcPts val="700"/>
+              </a:spcBef>
+            </a:pPr>
+            <a:r>
+              <a:rPr lang="en-US" sz="1800" dirty="0"/>
               <a:t>One node plus the witness lost: quorum lost, cluster offline</a:t>
             </a:r>
           </a:p>
@@ -24002,8 +23776,8 @@
               </a:spcBef>
             </a:pPr>
             <a:r>
-              <a:rPr lang="en-US" sz="2100" dirty="0"/>
-              <a:t>Power, cooling, cabling, out-of-band access</a:t>
+              <a:rPr lang="en-US" sz="1700" dirty="0"/>
+              <a:t>Management, compute, storage and OOB paths; gateways, DNS/NTP, routing, egress and return path</a:t>
             </a:r>
           </a:p>
           <a:p>
@@ -24013,8 +23787,8 @@
               </a:spcBef>
             </a:pPr>
             <a:r>
-              <a:rPr lang="en-US" sz="2100" dirty="0"/>
-              <a:t>Recommendation: Arc gateway (new deployments on 2506 or later; it cannot be enabled afterwards) or proxy plus Arc gateway</a:t>
+              <a:rPr lang="en-US" sz="1700" dirty="0"/>
+              <a:t>Full sanitized ToR/OOB/firewall exports; VLANs, ports, trunks, MTU, ACLs and NAT</a:t>
             </a:r>
           </a:p>
           <a:p>
@@ -24024,8 +23798,8 @@
               </a:spcBef>
             </a:pPr>
             <a:r>
-              <a:rPr lang="en-US" sz="2100" dirty="0"/>
-              <a:t>Preview constraint: the provisioning preview used here does not support the gateway</a:t>
+              <a:rPr lang="en-US" sz="1700" dirty="0"/>
+              <a:t>Recommendation: Arc gateway (new deployments on 2506 or later; it cannot be enabled afterwards) or proxy plus Arc gateway</a:t>
             </a:r>
           </a:p>
           <a:p>
@@ -24035,7 +23809,18 @@
               </a:spcBef>
             </a:pPr>
             <a:r>
-              <a:rPr lang="en-US" sz="2100" dirty="0"/>
+              <a:rPr lang="en-US" sz="1700" dirty="0"/>
+              <a:t>Preview constraint: the provisioning preview used here does not support the gateway</a:t>
+            </a:r>
+          </a:p>
+          <a:p>
+            <a:pPr>
+              <a:spcBef>
+                <a:spcPts val="700"/>
+              </a:spcBef>
+            </a:pPr>
+            <a:r>
+              <a:rPr lang="en-US" sz="1700" dirty="0"/>
               <a:t>Lab: direct egress with the full allow-list (D-024)</a:t>
             </a:r>
           </a:p>
@@ -24634,14 +24419,14 @@
           <a:p>
             <a:pPr algn="ctr"/>
             <a:r>
-              <a:rPr lang="en-US" sz="1300" i="1" dirty="0">
+              <a:rPr lang="en-US" sz="1000" i="1" dirty="0">
                 <a:solidFill>
                   <a:srgbClr val="C3FBFE"/>
                 </a:solidFill>
                 <a:latin typeface="Roboto"/>
                 <a:cs typeface="Roboto"/>
               </a:rPr>
-              <a:t>How the node ports become a supported network.</a:t>
+              <a:t>VLAN isolation and physical convergence are separate decisions; reviewed site evidence maps to approved Network ATC intents.</a:t>
             </a:r>
           </a:p>
         </p:txBody>
@@ -24654,8 +24439,8 @@
         </p:nvSpPr>
         <p:spPr>
           <a:xfrm>
-            <a:off x="457200" y="1975104"/>
-            <a:ext cx="2621280" cy="1920240"/>
+            <a:off x="457200" y="1691259"/>
+            <a:ext cx="2621280" cy="2487930"/>
           </a:xfrm>
           <a:prstGeom prst="roundRect">
             <a:avLst>
@@ -24687,7 +24472,7 @@
         </p:nvSpPr>
         <p:spPr>
           <a:xfrm>
-            <a:off x="621792" y="2157984"/>
+            <a:off x="621792" y="1874139"/>
             <a:ext cx="457200" cy="64008"/>
           </a:xfrm>
           <a:prstGeom prst="rect">
@@ -24716,8 +24501,8 @@
         </p:nvSpPr>
         <p:spPr>
           <a:xfrm>
-            <a:off x="548640" y="2295144"/>
-            <a:ext cx="2438400" cy="1508760"/>
+            <a:off x="548640" y="2011299"/>
+            <a:ext cx="2438400" cy="2076450"/>
           </a:xfrm>
           <a:prstGeom prst="rect">
             <a:avLst/>
@@ -24772,8 +24557,8 @@
         </p:nvSpPr>
         <p:spPr>
           <a:xfrm>
-            <a:off x="3261360" y="1975104"/>
-            <a:ext cx="2621280" cy="1920240"/>
+            <a:off x="3261360" y="1691259"/>
+            <a:ext cx="2621280" cy="2487930"/>
           </a:xfrm>
           <a:prstGeom prst="roundRect">
             <a:avLst>
@@ -24805,7 +24590,7 @@
         </p:nvSpPr>
         <p:spPr>
           <a:xfrm>
-            <a:off x="3425952" y="2157984"/>
+            <a:off x="3425952" y="1874139"/>
             <a:ext cx="457200" cy="64008"/>
           </a:xfrm>
           <a:prstGeom prst="rect">
@@ -24834,8 +24619,126 @@
         </p:nvSpPr>
         <p:spPr>
           <a:xfrm>
-            <a:off x="3352800" y="2295144"/>
-            <a:ext cx="2438400" cy="1508760"/>
+            <a:off x="3352800" y="2011299"/>
+            <a:ext cx="2438400" cy="2076450"/>
+          </a:xfrm>
+          <a:prstGeom prst="rect">
+            <a:avLst/>
+          </a:prstGeom>
+          <a:noFill/>
+          <a:ln>
+            <a:noFill/>
+          </a:ln>
+        </p:spPr>
+        <p:txBody>
+          <a:bodyPr wrap="square" lIns="73152" tIns="36576" rIns="73152" bIns="36576" rtlCol="0" anchor="t">
+            <a:noAutofit/>
+          </a:bodyPr>
+          <a:lstStyle/>
+          <a:p>
+            <a:pPr/>
+            <a:r>
+              <a:rPr lang="en-US" sz="1700" b="1" dirty="0">
+                <a:solidFill>
+                  <a:srgbClr val="98F8FE"/>
+                </a:solidFill>
+                <a:latin typeface="Roboto"/>
+                <a:cs typeface="Roboto"/>
+              </a:rPr>
+              <a:t>Management/compute</a:t>
+            </a:r>
+          </a:p>
+          <a:p>
+            <a:pPr>
+              <a:spcBef>
+                <a:spcPts val="600"/>
+              </a:spcBef>
+            </a:pPr>
+            <a:r>
+              <a:rPr lang="en-US" sz="1600" dirty="0">
+                <a:solidFill>
+                  <a:srgbClr val="C3FBFE"/>
+                </a:solidFill>
+                <a:latin typeface="Roboto"/>
+                <a:cs typeface="Roboto"/>
+              </a:rPr>
+              <a:t>same VLAN, separate VLANs on shared adapters, or dedicated adapters</a:t>
+            </a:r>
+          </a:p>
+        </p:txBody>
+      </p:sp>
+      <p:sp>
+        <p:nvSpPr>
+          <p:cNvPr id="11" name="Card 11"/>
+          <p:cNvSpPr/>
+          <p:nvPr/>
+        </p:nvSpPr>
+        <p:spPr>
+          <a:xfrm>
+            <a:off x="6065520" y="1691259"/>
+            <a:ext cx="2621280" cy="2487930"/>
+          </a:xfrm>
+          <a:prstGeom prst="roundRect">
+            <a:avLst>
+              <a:gd name="adj" fmla="val 6000"/>
+            </a:avLst>
+          </a:prstGeom>
+          <a:solidFill>
+            <a:srgbClr val="262929"/>
+          </a:solidFill>
+          <a:ln w="19050">
+            <a:solidFill>
+              <a:srgbClr val="98F8FE"/>
+            </a:solidFill>
+          </a:ln>
+        </p:spPr>
+        <p:txBody>
+          <a:bodyPr rtlCol="0" anchor="ctr"/>
+          <a:lstStyle/>
+          <a:p>
+            <a:endParaRPr lang="en-US" dirty="0"/>
+          </a:p>
+        </p:txBody>
+      </p:sp>
+      <p:sp>
+        <p:nvSpPr>
+          <p:cNvPr id="12" name="Rule 12"/>
+          <p:cNvSpPr/>
+          <p:nvPr/>
+        </p:nvSpPr>
+        <p:spPr>
+          <a:xfrm>
+            <a:off x="6230112" y="1874139"/>
+            <a:ext cx="457200" cy="64008"/>
+          </a:xfrm>
+          <a:prstGeom prst="rect">
+            <a:avLst/>
+          </a:prstGeom>
+          <a:solidFill>
+            <a:srgbClr val="FDBA12"/>
+          </a:solidFill>
+          <a:ln>
+            <a:noFill/>
+          </a:ln>
+        </p:spPr>
+        <p:txBody>
+          <a:bodyPr rtlCol="0" anchor="ctr"/>
+          <a:lstStyle/>
+          <a:p>
+            <a:endParaRPr lang="en-US" dirty="0"/>
+          </a:p>
+        </p:txBody>
+      </p:sp>
+      <p:sp>
+        <p:nvSpPr>
+          <p:cNvPr id="13" name="Text 13"/>
+          <p:cNvSpPr txBox="1"/>
+          <p:nvPr/>
+        </p:nvSpPr>
+        <p:spPr>
+          <a:xfrm>
+            <a:off x="6156960" y="2011299"/>
+            <a:ext cx="2438400" cy="2076450"/>
           </a:xfrm>
           <a:prstGeom prst="rect">
             <a:avLst/>
@@ -24864,112 +24767,7 @@
                 <a:latin typeface="Roboto"/>
                 <a:cs typeface="Roboto"/>
               </a:rPr>
-              <a:t>Dedicated VLANs; jumbo on storage; RDMA per adapter: iWARP (DCB optional) or RoCE (DCB required)</a:t>
-            </a:r>
-          </a:p>
-        </p:txBody>
-      </p:sp>
-      <p:sp>
-        <p:nvSpPr>
-          <p:cNvPr id="11" name="Card 11"/>
-          <p:cNvSpPr/>
-          <p:nvPr/>
-        </p:nvSpPr>
-        <p:spPr>
-          <a:xfrm>
-            <a:off x="6065520" y="1975104"/>
-            <a:ext cx="2621280" cy="1920240"/>
-          </a:xfrm>
-          <a:prstGeom prst="roundRect">
-            <a:avLst>
-              <a:gd name="adj" fmla="val 6000"/>
-            </a:avLst>
-          </a:prstGeom>
-          <a:solidFill>
-            <a:srgbClr val="262929"/>
-          </a:solidFill>
-          <a:ln w="19050">
-            <a:solidFill>
-              <a:srgbClr val="98F8FE"/>
-            </a:solidFill>
-          </a:ln>
-        </p:spPr>
-        <p:txBody>
-          <a:bodyPr rtlCol="0" anchor="ctr"/>
-          <a:lstStyle/>
-          <a:p>
-            <a:endParaRPr lang="en-US" dirty="0"/>
-          </a:p>
-        </p:txBody>
-      </p:sp>
-      <p:sp>
-        <p:nvSpPr>
-          <p:cNvPr id="12" name="Rule 12"/>
-          <p:cNvSpPr/>
-          <p:nvPr/>
-        </p:nvSpPr>
-        <p:spPr>
-          <a:xfrm>
-            <a:off x="6230112" y="2157984"/>
-            <a:ext cx="457200" cy="64008"/>
-          </a:xfrm>
-          <a:prstGeom prst="rect">
-            <a:avLst/>
-          </a:prstGeom>
-          <a:solidFill>
-            <a:srgbClr val="FDBA12"/>
-          </a:solidFill>
-          <a:ln>
-            <a:noFill/>
-          </a:ln>
-        </p:spPr>
-        <p:txBody>
-          <a:bodyPr rtlCol="0" anchor="ctr"/>
-          <a:lstStyle/>
-          <a:p>
-            <a:endParaRPr lang="en-US" dirty="0"/>
-          </a:p>
-        </p:txBody>
-      </p:sp>
-      <p:sp>
-        <p:nvSpPr>
-          <p:cNvPr id="13" name="Text 13"/>
-          <p:cNvSpPr txBox="1"/>
-          <p:nvPr/>
-        </p:nvSpPr>
-        <p:spPr>
-          <a:xfrm>
-            <a:off x="6156960" y="2295144"/>
-            <a:ext cx="2438400" cy="1508760"/>
-          </a:xfrm>
-          <a:prstGeom prst="rect">
-            <a:avLst/>
-          </a:prstGeom>
-          <a:noFill/>
-          <a:ln>
-            <a:noFill/>
-          </a:ln>
-        </p:spPr>
-        <p:txBody>
-          <a:bodyPr wrap="square" lIns="73152" tIns="36576" rIns="73152" bIns="36576" rtlCol="0" anchor="t">
-            <a:noAutofit/>
-          </a:bodyPr>
-          <a:lstStyle/>
-          <a:p>
-            <a:pPr>
-              <a:spcBef>
-                <a:spcPts val="0"/>
-              </a:spcBef>
-            </a:pPr>
-            <a:r>
-              <a:rPr lang="en-US" sz="1600" dirty="0">
-                <a:solidFill>
-                  <a:srgbClr val="98F8FE"/>
-                </a:solidFill>
-                <a:latin typeface="Roboto"/>
-                <a:cs typeface="Roboto"/>
-              </a:rPr>
-              <a:t>The 25 GbE adapters link at 10 GbE on this switch</a:t>
+              <a:t>Read back the approved choice; map ports/MACs, tagging, MTU and storage/RDMA requirements</a:t>
             </a:r>
           </a:p>
         </p:txBody>

</xml_diff>

<commit_message>
Regenerate attendee deck: GPU licence row - compute and AI with the free driver, desktop graphics acceleration needs NVIDIA vWS
Co-Authored-By: Claude Opus 5.5 <noreply@anthropic.com>
</commit_message>
<xml_diff>
--- a/presentation/Azure_Local_Discovery_to_Day2_NIC2026.pptx
+++ b/presentation/Azure_Local_Discovery_to_Day2_NIC2026.pptx
@@ -33291,7 +33291,7 @@
         </p:nvGraphicFramePr>
         <p:xfrm>
           <a:off x="457200" y="1517904"/>
-          <a:ext cx="8229600" cy="1868805"/>
+          <a:ext cx="8229600" cy="2188845"/>
         </p:xfrm>
         <a:graphic>
           <a:graphicData uri="http://schemas.openxmlformats.org/drawingml/2006/table">
@@ -33570,7 +33570,7 @@
                   </a:tcPr>
                 </a:tc>
               </a:tr>
-              <a:tr h="309753">
+              <a:tr h="629793">
                 <a:tc>
                   <a:txBody>
                     <a:bodyPr/>
@@ -33629,7 +33629,7 @@
                           <a:latin typeface="Roboto"/>
                           <a:cs typeface="Roboto"/>
                         </a:rPr>
-                        <a:t>None for DDA and the data center driver</a:t>
+                        <a:t>None for DDA and the data center driver (compute and AI); desktop graphics acceleration needs NVIDIA vWS</a:t>
                       </a:r>
                     </a:p>
                   </a:txBody>

</xml_diff>

<commit_message>
presentation: attendee deck regenerated - slide 3 shows a single "Photo montage shown live" panel (the montage is shown in the room only)
Co-Authored-By: Claude Opus 5.5 <noreply@anthropic.com>
</commit_message>
<xml_diff>
--- a/presentation/Azure_Local_Discovery_to_Day2_NIC2026.pptx
+++ b/presentation/Azure_Local_Discovery_to_Day2_NIC2026.pptx
@@ -23153,14 +23153,14 @@
       </p:sp>
       <p:sp>
         <p:nvSpPr>
-          <p:cNvPr id="3" name="Photo shown live 3"/>
+          <p:cNvPr id="3" name="Montage placeholder 3"/>
           <p:cNvSpPr/>
           <p:nvPr/>
         </p:nvSpPr>
         <p:spPr>
           <a:xfrm>
-            <a:off x="457200" y="896112"/>
-            <a:ext cx="2103120" cy="1682496"/>
+            <a:off x="1483360" y="914400"/>
+            <a:ext cx="6177280" cy="3474720"/>
           </a:xfrm>
           <a:prstGeom prst="rect">
             <a:avLst/>
@@ -23182,615 +23182,14 @@
           <a:p>
             <a:pPr algn="ctr"/>
             <a:r>
-              <a:rPr lang="en-US" sz="1300" b="1" dirty="0">
+              <a:rPr lang="en-US" sz="1800" b="1" dirty="0">
                 <a:solidFill>
                   <a:srgbClr val="98F8FE"/>
                 </a:solidFill>
                 <a:latin typeface="Roboto"/>
                 <a:cs typeface="Roboto"/>
               </a:rPr>
-              <a:t>Photo shown live</a:t>
-            </a:r>
-          </a:p>
-        </p:txBody>
-      </p:sp>
-      <p:sp>
-        <p:nvSpPr>
-          <p:cNvPr id="4" name="Caption 4"/>
-          <p:cNvSpPr/>
-          <p:nvPr/>
-        </p:nvSpPr>
-        <p:spPr>
-          <a:xfrm>
-            <a:off x="2670048" y="896112"/>
-            <a:ext cx="1810512" cy="1682496"/>
-          </a:xfrm>
-          <a:prstGeom prst="roundRect">
-            <a:avLst>
-              <a:gd name="adj" fmla="val 7000"/>
-            </a:avLst>
-          </a:prstGeom>
-          <a:solidFill>
-            <a:srgbClr val="FFFFFF"/>
-          </a:solidFill>
-          <a:ln w="15875">
-            <a:solidFill>
-              <a:srgbClr val="1A1B1B"/>
-            </a:solidFill>
-          </a:ln>
-        </p:spPr>
-        <p:txBody>
-          <a:bodyPr rtlCol="0" anchor="ctr"/>
-          <a:lstStyle/>
-          <a:p>
-            <a:endParaRPr lang="en-US" dirty="0"/>
-          </a:p>
-        </p:txBody>
-      </p:sp>
-      <p:sp>
-        <p:nvSpPr>
-          <p:cNvPr id="5" name="Rule 5"/>
-          <p:cNvSpPr/>
-          <p:nvPr/>
-        </p:nvSpPr>
-        <p:spPr>
-          <a:xfrm>
-            <a:off x="2816352" y="1078992"/>
-            <a:ext cx="457200" cy="64008"/>
-          </a:xfrm>
-          <a:prstGeom prst="rect">
-            <a:avLst/>
-          </a:prstGeom>
-          <a:solidFill>
-            <a:srgbClr val="FDBA12"/>
-          </a:solidFill>
-          <a:ln>
-            <a:noFill/>
-          </a:ln>
-        </p:spPr>
-        <p:txBody>
-          <a:bodyPr rtlCol="0" anchor="ctr"/>
-          <a:lstStyle/>
-          <a:p>
-            <a:endParaRPr lang="en-US" dirty="0"/>
-          </a:p>
-        </p:txBody>
-      </p:sp>
-      <p:sp>
-        <p:nvSpPr>
-          <p:cNvPr id="6" name="Text 6"/>
-          <p:cNvSpPr txBox="1"/>
-          <p:nvPr/>
-        </p:nvSpPr>
-        <p:spPr>
-          <a:xfrm>
-            <a:off x="2743200" y="1207008"/>
-            <a:ext cx="1664208" cy="1298448"/>
-          </a:xfrm>
-          <a:prstGeom prst="rect">
-            <a:avLst/>
-          </a:prstGeom>
-          <a:noFill/>
-          <a:ln>
-            <a:noFill/>
-          </a:ln>
-        </p:spPr>
-        <p:txBody>
-          <a:bodyPr wrap="square" lIns="73152" tIns="36576" rIns="73152" bIns="36576" rtlCol="0" anchor="t">
-            <a:noAutofit/>
-          </a:bodyPr>
-          <a:lstStyle/>
-          <a:p>
-            <a:pPr/>
-            <a:r>
-              <a:rPr lang="en-US" sz="1350" b="1" dirty="0">
-                <a:solidFill>
-                  <a:srgbClr val="1A1B1B"/>
-                </a:solidFill>
-                <a:latin typeface="Roboto"/>
-                <a:cs typeface="Roboto"/>
-              </a:rPr>
-              <a:t>The boys and the donkeys</a:t>
-            </a:r>
-          </a:p>
-          <a:p>
-            <a:pPr>
-              <a:spcBef>
-                <a:spcPts val="400"/>
-              </a:spcBef>
-            </a:pPr>
-            <a:r>
-              <a:rPr lang="en-US" sz="900" dirty="0">
-                <a:solidFill>
-                  <a:srgbClr val="193233"/>
-                </a:solidFill>
-                <a:latin typeface="Roboto"/>
-                <a:cs typeface="Roboto"/>
-              </a:rPr>
-              <a:t>Three boys, two donkeys, one fence. The donkeys have the better uptime.</a:t>
-            </a:r>
-          </a:p>
-        </p:txBody>
-      </p:sp>
-      <p:sp>
-        <p:nvSpPr>
-          <p:cNvPr id="7" name="Photo shown live 7"/>
-          <p:cNvSpPr/>
-          <p:nvPr/>
-        </p:nvSpPr>
-        <p:spPr>
-          <a:xfrm>
-            <a:off x="4663440" y="896112"/>
-            <a:ext cx="2103120" cy="1682496"/>
-          </a:xfrm>
-          <a:prstGeom prst="rect">
-            <a:avLst/>
-          </a:prstGeom>
-          <a:solidFill>
-            <a:srgbClr val="1A1B1B"/>
-          </a:solidFill>
-          <a:ln w="31750">
-            <a:solidFill>
-              <a:srgbClr val="1A1B1B"/>
-            </a:solidFill>
-          </a:ln>
-        </p:spPr>
-        <p:txBody>
-          <a:bodyPr wrap="square" lIns="73152" tIns="36576" rIns="73152" bIns="36576" rtlCol="0" anchor="ctr">
-            <a:noAutofit/>
-          </a:bodyPr>
-          <a:lstStyle/>
-          <a:p>
-            <a:pPr algn="ctr"/>
-            <a:r>
-              <a:rPr lang="en-US" sz="1300" b="1" dirty="0">
-                <a:solidFill>
-                  <a:srgbClr val="98F8FE"/>
-                </a:solidFill>
-                <a:latin typeface="Roboto"/>
-                <a:cs typeface="Roboto"/>
-              </a:rPr>
-              <a:t>Photo shown live</a:t>
-            </a:r>
-          </a:p>
-        </p:txBody>
-      </p:sp>
-      <p:sp>
-        <p:nvSpPr>
-          <p:cNvPr id="8" name="Caption 8"/>
-          <p:cNvSpPr/>
-          <p:nvPr/>
-        </p:nvSpPr>
-        <p:spPr>
-          <a:xfrm>
-            <a:off x="6876288" y="896112"/>
-            <a:ext cx="1810512" cy="1682496"/>
-          </a:xfrm>
-          <a:prstGeom prst="roundRect">
-            <a:avLst>
-              <a:gd name="adj" fmla="val 7000"/>
-            </a:avLst>
-          </a:prstGeom>
-          <a:solidFill>
-            <a:srgbClr val="FFFFFF"/>
-          </a:solidFill>
-          <a:ln w="15875">
-            <a:solidFill>
-              <a:srgbClr val="1A1B1B"/>
-            </a:solidFill>
-          </a:ln>
-        </p:spPr>
-        <p:txBody>
-          <a:bodyPr rtlCol="0" anchor="ctr"/>
-          <a:lstStyle/>
-          <a:p>
-            <a:endParaRPr lang="en-US" dirty="0"/>
-          </a:p>
-        </p:txBody>
-      </p:sp>
-      <p:sp>
-        <p:nvSpPr>
-          <p:cNvPr id="9" name="Rule 9"/>
-          <p:cNvSpPr/>
-          <p:nvPr/>
-        </p:nvSpPr>
-        <p:spPr>
-          <a:xfrm>
-            <a:off x="7022592" y="1078992"/>
-            <a:ext cx="457200" cy="64008"/>
-          </a:xfrm>
-          <a:prstGeom prst="rect">
-            <a:avLst/>
-          </a:prstGeom>
-          <a:solidFill>
-            <a:srgbClr val="FDBA12"/>
-          </a:solidFill>
-          <a:ln>
-            <a:noFill/>
-          </a:ln>
-        </p:spPr>
-        <p:txBody>
-          <a:bodyPr rtlCol="0" anchor="ctr"/>
-          <a:lstStyle/>
-          <a:p>
-            <a:endParaRPr lang="en-US" dirty="0"/>
-          </a:p>
-        </p:txBody>
-      </p:sp>
-      <p:sp>
-        <p:nvSpPr>
-          <p:cNvPr id="10" name="Text 10"/>
-          <p:cNvSpPr txBox="1"/>
-          <p:nvPr/>
-        </p:nvSpPr>
-        <p:spPr>
-          <a:xfrm>
-            <a:off x="6949440" y="1207008"/>
-            <a:ext cx="1664208" cy="1298448"/>
-          </a:xfrm>
-          <a:prstGeom prst="rect">
-            <a:avLst/>
-          </a:prstGeom>
-          <a:noFill/>
-          <a:ln>
-            <a:noFill/>
-          </a:ln>
-        </p:spPr>
-        <p:txBody>
-          <a:bodyPr wrap="square" lIns="73152" tIns="36576" rIns="73152" bIns="36576" rtlCol="0" anchor="t">
-            <a:noAutofit/>
-          </a:bodyPr>
-          <a:lstStyle/>
-          <a:p>
-            <a:pPr/>
-            <a:r>
-              <a:rPr lang="en-US" sz="1350" b="1" dirty="0">
-                <a:solidFill>
-                  <a:srgbClr val="1A1B1B"/>
-                </a:solidFill>
-                <a:latin typeface="Roboto"/>
-                <a:cs typeface="Roboto"/>
-              </a:rPr>
-              <a:t>Viking practice</a:t>
-            </a:r>
-          </a:p>
-          <a:p>
-            <a:pPr>
-              <a:spcBef>
-                <a:spcPts val="400"/>
-              </a:spcBef>
-            </a:pPr>
-            <a:r>
-              <a:rPr lang="en-US" sz="900" dirty="0">
-                <a:solidFill>
-                  <a:srgbClr val="193233"/>
-                </a:solidFill>
-                <a:latin typeface="Roboto"/>
-                <a:cs typeface="Roboto"/>
-              </a:rPr>
-              <a:t>My son and me, rehearsing for Oslo years before the invitation arrived.</a:t>
-            </a:r>
-          </a:p>
-        </p:txBody>
-      </p:sp>
-      <p:sp>
-        <p:nvSpPr>
-          <p:cNvPr id="11" name="Photo shown live 11"/>
-          <p:cNvSpPr/>
-          <p:nvPr/>
-        </p:nvSpPr>
-        <p:spPr>
-          <a:xfrm>
-            <a:off x="457200" y="2724912"/>
-            <a:ext cx="2103120" cy="1682496"/>
-          </a:xfrm>
-          <a:prstGeom prst="rect">
-            <a:avLst/>
-          </a:prstGeom>
-          <a:solidFill>
-            <a:srgbClr val="1A1B1B"/>
-          </a:solidFill>
-          <a:ln w="31750">
-            <a:solidFill>
-              <a:srgbClr val="1A1B1B"/>
-            </a:solidFill>
-          </a:ln>
-        </p:spPr>
-        <p:txBody>
-          <a:bodyPr wrap="square" lIns="73152" tIns="36576" rIns="73152" bIns="36576" rtlCol="0" anchor="ctr">
-            <a:noAutofit/>
-          </a:bodyPr>
-          <a:lstStyle/>
-          <a:p>
-            <a:pPr algn="ctr"/>
-            <a:r>
-              <a:rPr lang="en-US" sz="1300" b="1" dirty="0">
-                <a:solidFill>
-                  <a:srgbClr val="98F8FE"/>
-                </a:solidFill>
-                <a:latin typeface="Roboto"/>
-                <a:cs typeface="Roboto"/>
-              </a:rPr>
-              <a:t>Photo shown live</a:t>
-            </a:r>
-          </a:p>
-        </p:txBody>
-      </p:sp>
-      <p:sp>
-        <p:nvSpPr>
-          <p:cNvPr id="12" name="Caption 12"/>
-          <p:cNvSpPr/>
-          <p:nvPr/>
-        </p:nvSpPr>
-        <p:spPr>
-          <a:xfrm>
-            <a:off x="2670048" y="2724912"/>
-            <a:ext cx="1810512" cy="1682496"/>
-          </a:xfrm>
-          <a:prstGeom prst="roundRect">
-            <a:avLst>
-              <a:gd name="adj" fmla="val 7000"/>
-            </a:avLst>
-          </a:prstGeom>
-          <a:solidFill>
-            <a:srgbClr val="FFFFFF"/>
-          </a:solidFill>
-          <a:ln w="15875">
-            <a:solidFill>
-              <a:srgbClr val="1A1B1B"/>
-            </a:solidFill>
-          </a:ln>
-        </p:spPr>
-        <p:txBody>
-          <a:bodyPr rtlCol="0" anchor="ctr"/>
-          <a:lstStyle/>
-          <a:p>
-            <a:endParaRPr lang="en-US" dirty="0"/>
-          </a:p>
-        </p:txBody>
-      </p:sp>
-      <p:sp>
-        <p:nvSpPr>
-          <p:cNvPr id="13" name="Rule 13"/>
-          <p:cNvSpPr/>
-          <p:nvPr/>
-        </p:nvSpPr>
-        <p:spPr>
-          <a:xfrm>
-            <a:off x="2816352" y="2907792"/>
-            <a:ext cx="457200" cy="64008"/>
-          </a:xfrm>
-          <a:prstGeom prst="rect">
-            <a:avLst/>
-          </a:prstGeom>
-          <a:solidFill>
-            <a:srgbClr val="FDBA12"/>
-          </a:solidFill>
-          <a:ln>
-            <a:noFill/>
-          </a:ln>
-        </p:spPr>
-        <p:txBody>
-          <a:bodyPr rtlCol="0" anchor="ctr"/>
-          <a:lstStyle/>
-          <a:p>
-            <a:endParaRPr lang="en-US" dirty="0"/>
-          </a:p>
-        </p:txBody>
-      </p:sp>
-      <p:sp>
-        <p:nvSpPr>
-          <p:cNvPr id="14" name="Text 14"/>
-          <p:cNvSpPr txBox="1"/>
-          <p:nvPr/>
-        </p:nvSpPr>
-        <p:spPr>
-          <a:xfrm>
-            <a:off x="2743200" y="3035808"/>
-            <a:ext cx="1664208" cy="1298448"/>
-          </a:xfrm>
-          <a:prstGeom prst="rect">
-            <a:avLst/>
-          </a:prstGeom>
-          <a:noFill/>
-          <a:ln>
-            <a:noFill/>
-          </a:ln>
-        </p:spPr>
-        <p:txBody>
-          <a:bodyPr wrap="square" lIns="73152" tIns="36576" rIns="73152" bIns="36576" rtlCol="0" anchor="t">
-            <a:noAutofit/>
-          </a:bodyPr>
-          <a:lstStyle/>
-          <a:p>
-            <a:pPr/>
-            <a:r>
-              <a:rPr lang="en-US" sz="1350" b="1" dirty="0">
-                <a:solidFill>
-                  <a:srgbClr val="1A1B1B"/>
-                </a:solidFill>
-                <a:latin typeface="Roboto"/>
-                <a:cs typeface="Roboto"/>
-              </a:rPr>
-              <a:t>Head of security</a:t>
-            </a:r>
-          </a:p>
-          <a:p>
-            <a:pPr>
-              <a:spcBef>
-                <a:spcPts val="400"/>
-              </a:spcBef>
-            </a:pPr>
-            <a:r>
-              <a:rPr lang="en-US" sz="900" dirty="0">
-                <a:solidFill>
-                  <a:srgbClr val="193233"/>
-                </a:solidFill>
-                <a:latin typeface="Roboto"/>
-                <a:cs typeface="Roboto"/>
-              </a:rPr>
-              <a:t>The dog. Approves every change, reads none of them.</a:t>
-            </a:r>
-          </a:p>
-        </p:txBody>
-      </p:sp>
-      <p:sp>
-        <p:nvSpPr>
-          <p:cNvPr id="15" name="Photo shown live 15"/>
-          <p:cNvSpPr/>
-          <p:nvPr/>
-        </p:nvSpPr>
-        <p:spPr>
-          <a:xfrm>
-            <a:off x="4663440" y="2724912"/>
-            <a:ext cx="2103120" cy="1682496"/>
-          </a:xfrm>
-          <a:prstGeom prst="rect">
-            <a:avLst/>
-          </a:prstGeom>
-          <a:solidFill>
-            <a:srgbClr val="1A1B1B"/>
-          </a:solidFill>
-          <a:ln w="31750">
-            <a:solidFill>
-              <a:srgbClr val="1A1B1B"/>
-            </a:solidFill>
-          </a:ln>
-        </p:spPr>
-        <p:txBody>
-          <a:bodyPr wrap="square" lIns="73152" tIns="36576" rIns="73152" bIns="36576" rtlCol="0" anchor="ctr">
-            <a:noAutofit/>
-          </a:bodyPr>
-          <a:lstStyle/>
-          <a:p>
-            <a:pPr algn="ctr"/>
-            <a:r>
-              <a:rPr lang="en-US" sz="1300" b="1" dirty="0">
-                <a:solidFill>
-                  <a:srgbClr val="98F8FE"/>
-                </a:solidFill>
-                <a:latin typeface="Roboto"/>
-                <a:cs typeface="Roboto"/>
-              </a:rPr>
-              <a:t>Photo shown live</a:t>
-            </a:r>
-          </a:p>
-        </p:txBody>
-      </p:sp>
-      <p:sp>
-        <p:nvSpPr>
-          <p:cNvPr id="16" name="Caption 16"/>
-          <p:cNvSpPr/>
-          <p:nvPr/>
-        </p:nvSpPr>
-        <p:spPr>
-          <a:xfrm>
-            <a:off x="6876288" y="2724912"/>
-            <a:ext cx="1810512" cy="1682496"/>
-          </a:xfrm>
-          <a:prstGeom prst="roundRect">
-            <a:avLst>
-              <a:gd name="adj" fmla="val 7000"/>
-            </a:avLst>
-          </a:prstGeom>
-          <a:solidFill>
-            <a:srgbClr val="FFFFFF"/>
-          </a:solidFill>
-          <a:ln w="15875">
-            <a:solidFill>
-              <a:srgbClr val="1A1B1B"/>
-            </a:solidFill>
-          </a:ln>
-        </p:spPr>
-        <p:txBody>
-          <a:bodyPr rtlCol="0" anchor="ctr"/>
-          <a:lstStyle/>
-          <a:p>
-            <a:endParaRPr lang="en-US" dirty="0"/>
-          </a:p>
-        </p:txBody>
-      </p:sp>
-      <p:sp>
-        <p:nvSpPr>
-          <p:cNvPr id="17" name="Rule 17"/>
-          <p:cNvSpPr/>
-          <p:nvPr/>
-        </p:nvSpPr>
-        <p:spPr>
-          <a:xfrm>
-            <a:off x="7022592" y="2907792"/>
-            <a:ext cx="457200" cy="64008"/>
-          </a:xfrm>
-          <a:prstGeom prst="rect">
-            <a:avLst/>
-          </a:prstGeom>
-          <a:solidFill>
-            <a:srgbClr val="FDBA12"/>
-          </a:solidFill>
-          <a:ln>
-            <a:noFill/>
-          </a:ln>
-        </p:spPr>
-        <p:txBody>
-          <a:bodyPr rtlCol="0" anchor="ctr"/>
-          <a:lstStyle/>
-          <a:p>
-            <a:endParaRPr lang="en-US" dirty="0"/>
-          </a:p>
-        </p:txBody>
-      </p:sp>
-      <p:sp>
-        <p:nvSpPr>
-          <p:cNvPr id="18" name="Text 18"/>
-          <p:cNvSpPr txBox="1"/>
-          <p:nvPr/>
-        </p:nvSpPr>
-        <p:spPr>
-          <a:xfrm>
-            <a:off x="6949440" y="3035808"/>
-            <a:ext cx="1664208" cy="1298448"/>
-          </a:xfrm>
-          <a:prstGeom prst="rect">
-            <a:avLst/>
-          </a:prstGeom>
-          <a:noFill/>
-          <a:ln>
-            <a:noFill/>
-          </a:ln>
-        </p:spPr>
-        <p:txBody>
-          <a:bodyPr wrap="square" lIns="73152" tIns="36576" rIns="73152" bIns="36576" rtlCol="0" anchor="t">
-            <a:noAutofit/>
-          </a:bodyPr>
-          <a:lstStyle/>
-          <a:p>
-            <a:pPr/>
-            <a:r>
-              <a:rPr lang="en-US" sz="1350" b="1" dirty="0">
-                <a:solidFill>
-                  <a:srgbClr val="1A1B1B"/>
-                </a:solidFill>
-                <a:latin typeface="Roboto"/>
-                <a:cs typeface="Roboto"/>
-              </a:rPr>
-              <a:t>Change advisory board</a:t>
-            </a:r>
-          </a:p>
-          <a:p>
-            <a:pPr>
-              <a:spcBef>
-                <a:spcPts val="400"/>
-              </a:spcBef>
-            </a:pPr>
-            <a:r>
-              <a:rPr lang="en-US" sz="900" dirty="0">
-                <a:solidFill>
-                  <a:srgbClr val="193233"/>
-                </a:solidFill>
-                <a:latin typeface="Roboto"/>
-                <a:cs typeface="Roboto"/>
-              </a:rPr>
-              <a:t>The chicken has concerns. So do I.</a:t>
+              <a:t>Photo montage shown live</a:t>
             </a:r>
           </a:p>
         </p:txBody>

</xml_diff>